<commit_message>
chore: sync working tree — survey UI fixes, logs, media, tools
- frontend: photo card layout + Hapus button, allow localhost image
  optimizer in dev (Next 16 blocks loopback by default), remove status
  badge beside survey detail title
- backend: logs/survey model + serializer updates, soft-delete
  migration, uploaded survey photos
- mobile: api/database service updates
- misc: dashboard report tools, crash logs, page audit, backups

Co-Authored-By: Claude Fable 5 <noreply@anthropic.com>
</commit_message>
<xml_diff>
--- a/Presentation ommha.pptx
+++ b/Presentation ommha.pptx
@@ -5,7 +5,7 @@
     <p:sldMasterId id="2147483672" r:id="rId1"/>
   </p:sldMasterIdLst>
   <p:notesMasterIdLst>
-    <p:notesMasterId r:id="rId14"/>
+    <p:notesMasterId r:id="rId13"/>
   </p:notesMasterIdLst>
   <p:sldIdLst>
     <p:sldId id="290" r:id="rId2"/>
@@ -16,10 +16,9 @@
     <p:sldId id="295" r:id="rId7"/>
     <p:sldId id="296" r:id="rId8"/>
     <p:sldId id="297" r:id="rId9"/>
-    <p:sldId id="298" r:id="rId10"/>
-    <p:sldId id="299" r:id="rId11"/>
-    <p:sldId id="300" r:id="rId12"/>
-    <p:sldId id="302" r:id="rId13"/>
+    <p:sldId id="299" r:id="rId10"/>
+    <p:sldId id="300" r:id="rId11"/>
+    <p:sldId id="302" r:id="rId12"/>
   </p:sldIdLst>
   <p:sldSz cx="12192000" cy="6858000"/>
   <p:notesSz cx="6858000" cy="9144000"/>
@@ -468,90 +467,6 @@
     </a:lvl9pPr>
   </p:notesStyle>
 </p:notesMaster>
-</file>
-
-<file path=ppt/notesSlides/notesSlide1.xml><?xml version="1.0" encoding="utf-8"?>
-<p:notes xmlns:a="http://schemas.openxmlformats.org/drawingml/2006/main" xmlns:r="http://schemas.openxmlformats.org/officeDocument/2006/relationships" xmlns:p="http://schemas.openxmlformats.org/presentationml/2006/main">
-  <p:cSld>
-    <p:spTree>
-      <p:nvGrpSpPr>
-        <p:cNvPr id="1" name=""/>
-        <p:cNvGrpSpPr/>
-        <p:nvPr/>
-      </p:nvGrpSpPr>
-      <p:grpSpPr>
-        <a:xfrm>
-          <a:off x="0" y="0"/>
-          <a:ext cx="0" cy="0"/>
-          <a:chOff x="0" y="0"/>
-          <a:chExt cx="0" cy="0"/>
-        </a:xfrm>
-      </p:grpSpPr>
-      <p:sp>
-        <p:nvSpPr>
-          <p:cNvPr id="2" name="Slide Image Placeholder 1"/>
-          <p:cNvSpPr>
-            <a:spLocks noGrp="1" noRot="1" noChangeAspect="1"/>
-          </p:cNvSpPr>
-          <p:nvPr>
-            <p:ph type="sldImg"/>
-          </p:nvPr>
-        </p:nvSpPr>
-        <p:spPr/>
-      </p:sp>
-      <p:sp>
-        <p:nvSpPr>
-          <p:cNvPr id="3" name="Notes Placeholder 2"/>
-          <p:cNvSpPr>
-            <a:spLocks noGrp="1"/>
-          </p:cNvSpPr>
-          <p:nvPr>
-            <p:ph type="body" idx="1"/>
-          </p:nvPr>
-        </p:nvSpPr>
-        <p:spPr/>
-        <p:txBody>
-          <a:bodyPr/>
-          <a:lstStyle/>
-          <a:p>
-            <a:endParaRPr lang="en-US" dirty="0"/>
-          </a:p>
-        </p:txBody>
-      </p:sp>
-      <p:sp>
-        <p:nvSpPr>
-          <p:cNvPr id="4" name="Slide Number Placeholder 3"/>
-          <p:cNvSpPr>
-            <a:spLocks noGrp="1"/>
-          </p:cNvSpPr>
-          <p:nvPr>
-            <p:ph type="sldNum" sz="quarter" idx="5"/>
-          </p:nvPr>
-        </p:nvSpPr>
-        <p:spPr/>
-        <p:txBody>
-          <a:bodyPr/>
-          <a:lstStyle/>
-          <a:p>
-            <a:fld id="{DF3A614F-0164-9946-B71E-AD6931CA26B1}" type="slidenum">
-              <a:rPr lang="en-US" smtClean="0"/>
-              <a:t>9</a:t>
-            </a:fld>
-            <a:endParaRPr lang="en-US"/>
-          </a:p>
-        </p:txBody>
-      </p:sp>
-    </p:spTree>
-    <p:extLst>
-      <p:ext uri="{BB962C8B-B14F-4D97-AF65-F5344CB8AC3E}">
-        <p14:creationId xmlns:p14="http://schemas.microsoft.com/office/powerpoint/2010/main" val="993706170"/>
-      </p:ext>
-    </p:extLst>
-  </p:cSld>
-  <p:clrMapOvr>
-    <a:masterClrMapping/>
-  </p:clrMapOvr>
-</p:notes>
 </file>
 
 <file path=ppt/slideLayouts/slideLayout1.xml><?xml version="1.0" encoding="utf-8"?>
@@ -3980,1042 +3895,6 @@
           <p:cNvPr id="2" name="Title 1">
             <a:extLst>
               <a:ext uri="{FF2B5EF4-FFF2-40B4-BE49-F238E27FC236}">
-                <a16:creationId xmlns:a16="http://schemas.microsoft.com/office/drawing/2014/main" id="{957AFCFC-0AB1-ACF3-1CDC-BF09E9C23D47}"/>
-              </a:ext>
-            </a:extLst>
-          </p:cNvPr>
-          <p:cNvSpPr>
-            <a:spLocks noGrp="1"/>
-          </p:cNvSpPr>
-          <p:nvPr>
-            <p:ph type="title"/>
-          </p:nvPr>
-        </p:nvSpPr>
-        <p:spPr/>
-        <p:txBody>
-          <a:bodyPr/>
-          <a:lstStyle/>
-          <a:p>
-            <a:r>
-              <a:rPr lang="en-US"/>
-              <a:t>Fitur Unggulan</a:t>
-            </a:r>
-          </a:p>
-        </p:txBody>
-      </p:sp>
-      <p:sp>
-        <p:nvSpPr>
-          <p:cNvPr id="3" name="Oval 2">
-            <a:extLst>
-              <a:ext uri="{FF2B5EF4-FFF2-40B4-BE49-F238E27FC236}">
-                <a16:creationId xmlns:a16="http://schemas.microsoft.com/office/drawing/2014/main" id="{5C241E56-2D47-5543-8C48-FC7EB49164DB}"/>
-              </a:ext>
-            </a:extLst>
-          </p:cNvPr>
-          <p:cNvSpPr/>
-          <p:nvPr/>
-        </p:nvSpPr>
-        <p:spPr>
-          <a:xfrm>
-            <a:off x="2159000" y="2032000"/>
-            <a:ext cx="762000" cy="762000"/>
-          </a:xfrm>
-          <a:prstGeom prst="ellipse">
-            <a:avLst/>
-          </a:prstGeom>
-          <a:solidFill>
-            <a:srgbClr val="2A68A8"/>
-          </a:solidFill>
-          <a:ln w="19050" cap="flat" cmpd="sng" algn="ctr">
-            <a:noFill/>
-            <a:prstDash val="solid"/>
-            <a:miter lim="800000"/>
-          </a:ln>
-        </p:spPr>
-        <p:style>
-          <a:lnRef idx="2">
-            <a:schemeClr val="accent1">
-              <a:shade val="15000"/>
-            </a:schemeClr>
-          </a:lnRef>
-          <a:fillRef idx="1">
-            <a:schemeClr val="accent1"/>
-          </a:fillRef>
-          <a:effectRef idx="0">
-            <a:schemeClr val="accent1"/>
-          </a:effectRef>
-          <a:fontRef idx="minor">
-            <a:schemeClr val="lt1"/>
-          </a:fontRef>
-        </p:style>
-        <p:txBody>
-          <a:bodyPr vertOverflow="clip" horzOverflow="clip" rtlCol="0" anchor="t"/>
-          <a:lstStyle/>
-          <a:p>
-            <a:pPr algn="l"/>
-            <a:endParaRPr lang="en-US"/>
-          </a:p>
-        </p:txBody>
-      </p:sp>
-      <p:sp>
-        <p:nvSpPr>
-          <p:cNvPr id="4" name="TextBox 3">
-            <a:extLst>
-              <a:ext uri="{FF2B5EF4-FFF2-40B4-BE49-F238E27FC236}">
-                <a16:creationId xmlns:a16="http://schemas.microsoft.com/office/drawing/2014/main" id="{AA86062D-5C5C-434F-9569-05CBD38084CE}"/>
-              </a:ext>
-            </a:extLst>
-          </p:cNvPr>
-          <p:cNvSpPr txBox="1"/>
-          <p:nvPr/>
-        </p:nvSpPr>
-        <p:spPr>
-          <a:xfrm>
-            <a:off x="889000" y="2946400"/>
-            <a:ext cx="3302000" cy="355600"/>
-          </a:xfrm>
-          <a:prstGeom prst="rect">
-            <a:avLst/>
-          </a:prstGeom>
-          <a:noFill/>
-        </p:spPr>
-        <p:txBody>
-          <a:bodyPr vertOverflow="overflow" vert="horz" wrap="square" rtlCol="0" anchor="t">
-            <a:noAutofit/>
-          </a:bodyPr>
-          <a:lstStyle/>
-          <a:p>
-            <a:pPr algn="l"/>
-            <a:r>
-              <a:rPr lang="en-US" sz="1600" b="1">
-                <a:solidFill>
-                  <a:srgbClr val="1A1A1A"/>
-                </a:solidFill>
-              </a:rPr>
-              <a:t>Form Pintar Bercabang</a:t>
-            </a:r>
-          </a:p>
-        </p:txBody>
-      </p:sp>
-      <p:sp>
-        <p:nvSpPr>
-          <p:cNvPr id="5" name="TextBox 4">
-            <a:extLst>
-              <a:ext uri="{FF2B5EF4-FFF2-40B4-BE49-F238E27FC236}">
-                <a16:creationId xmlns:a16="http://schemas.microsoft.com/office/drawing/2014/main" id="{319BCBF9-539A-5843-B3B0-238DF24A27F7}"/>
-              </a:ext>
-            </a:extLst>
-          </p:cNvPr>
-          <p:cNvSpPr txBox="1"/>
-          <p:nvPr/>
-        </p:nvSpPr>
-        <p:spPr>
-          <a:xfrm>
-            <a:off x="990600" y="3327400"/>
-            <a:ext cx="3098800" cy="635000"/>
-          </a:xfrm>
-          <a:prstGeom prst="rect">
-            <a:avLst/>
-          </a:prstGeom>
-          <a:noFill/>
-        </p:spPr>
-        <p:txBody>
-          <a:bodyPr vertOverflow="overflow" vert="horz" wrap="square" rtlCol="0" anchor="t">
-            <a:noAutofit/>
-          </a:bodyPr>
-          <a:lstStyle/>
-          <a:p>
-            <a:pPr algn="l"/>
-            <a:r>
-              <a:rPr lang="en-US" sz="1400">
-                <a:solidFill>
-                  <a:srgbClr val="374151"/>
-                </a:solidFill>
-              </a:rPr>
-              <a:t>Hemat waktu surveyor di lapangan.</a:t>
-            </a:r>
-          </a:p>
-        </p:txBody>
-      </p:sp>
-      <p:sp>
-        <p:nvSpPr>
-          <p:cNvPr id="6" name="Oval 5">
-            <a:extLst>
-              <a:ext uri="{FF2B5EF4-FFF2-40B4-BE49-F238E27FC236}">
-                <a16:creationId xmlns:a16="http://schemas.microsoft.com/office/drawing/2014/main" id="{D46F3AE5-4C89-834F-86E2-CEFC39F4DD48}"/>
-              </a:ext>
-            </a:extLst>
-          </p:cNvPr>
-          <p:cNvSpPr/>
-          <p:nvPr/>
-        </p:nvSpPr>
-        <p:spPr>
-          <a:xfrm>
-            <a:off x="5715000" y="2032000"/>
-            <a:ext cx="762000" cy="762000"/>
-          </a:xfrm>
-          <a:prstGeom prst="ellipse">
-            <a:avLst/>
-          </a:prstGeom>
-          <a:solidFill>
-            <a:srgbClr val="2A68A8"/>
-          </a:solidFill>
-          <a:ln w="19050" cap="flat" cmpd="sng" algn="ctr">
-            <a:noFill/>
-            <a:prstDash val="solid"/>
-            <a:miter lim="800000"/>
-          </a:ln>
-        </p:spPr>
-        <p:style>
-          <a:lnRef idx="2">
-            <a:schemeClr val="accent1">
-              <a:shade val="15000"/>
-            </a:schemeClr>
-          </a:lnRef>
-          <a:fillRef idx="1">
-            <a:schemeClr val="accent1"/>
-          </a:fillRef>
-          <a:effectRef idx="0">
-            <a:schemeClr val="accent1"/>
-          </a:effectRef>
-          <a:fontRef idx="minor">
-            <a:schemeClr val="lt1"/>
-          </a:fontRef>
-        </p:style>
-        <p:txBody>
-          <a:bodyPr vertOverflow="clip" horzOverflow="clip" rtlCol="0" anchor="t"/>
-          <a:lstStyle/>
-          <a:p>
-            <a:pPr algn="l"/>
-            <a:endParaRPr lang="en-US"/>
-          </a:p>
-        </p:txBody>
-      </p:sp>
-      <p:sp>
-        <p:nvSpPr>
-          <p:cNvPr id="7" name="TextBox 6">
-            <a:extLst>
-              <a:ext uri="{FF2B5EF4-FFF2-40B4-BE49-F238E27FC236}">
-                <a16:creationId xmlns:a16="http://schemas.microsoft.com/office/drawing/2014/main" id="{3344083B-EDB2-3A42-A1D2-E7235593BA31}"/>
-              </a:ext>
-            </a:extLst>
-          </p:cNvPr>
-          <p:cNvSpPr txBox="1"/>
-          <p:nvPr/>
-        </p:nvSpPr>
-        <p:spPr>
-          <a:xfrm>
-            <a:off x="4445000" y="2946400"/>
-            <a:ext cx="3302000" cy="355600"/>
-          </a:xfrm>
-          <a:prstGeom prst="rect">
-            <a:avLst/>
-          </a:prstGeom>
-          <a:noFill/>
-        </p:spPr>
-        <p:txBody>
-          <a:bodyPr vertOverflow="overflow" vert="horz" wrap="square" rtlCol="0" anchor="t">
-            <a:noAutofit/>
-          </a:bodyPr>
-          <a:lstStyle/>
-          <a:p>
-            <a:pPr algn="l"/>
-            <a:r>
-              <a:rPr lang="en-US" sz="1600" b="1">
-                <a:solidFill>
-                  <a:srgbClr val="1A1A1A"/>
-                </a:solidFill>
-              </a:rPr>
-              <a:t>Klasifikasi Otomatis</a:t>
-            </a:r>
-          </a:p>
-        </p:txBody>
-      </p:sp>
-      <p:sp>
-        <p:nvSpPr>
-          <p:cNvPr id="8" name="TextBox 7">
-            <a:extLst>
-              <a:ext uri="{FF2B5EF4-FFF2-40B4-BE49-F238E27FC236}">
-                <a16:creationId xmlns:a16="http://schemas.microsoft.com/office/drawing/2014/main" id="{F13BDB47-C124-EA45-BF66-86525646CE44}"/>
-              </a:ext>
-            </a:extLst>
-          </p:cNvPr>
-          <p:cNvSpPr txBox="1"/>
-          <p:nvPr/>
-        </p:nvSpPr>
-        <p:spPr>
-          <a:xfrm>
-            <a:off x="4546600" y="3327400"/>
-            <a:ext cx="3098800" cy="635000"/>
-          </a:xfrm>
-          <a:prstGeom prst="rect">
-            <a:avLst/>
-          </a:prstGeom>
-          <a:noFill/>
-        </p:spPr>
-        <p:txBody>
-          <a:bodyPr vertOverflow="overflow" vert="horz" wrap="square" rtlCol="0" anchor="t">
-            <a:noAutofit/>
-          </a:bodyPr>
-          <a:lstStyle/>
-          <a:p>
-            <a:pPr algn="l"/>
-            <a:r>
-              <a:rPr lang="en-US" sz="1400">
-                <a:solidFill>
-                  <a:srgbClr val="374151"/>
-                </a:solidFill>
-              </a:rPr>
-              <a:t>Mengikuti standar DESDE-LTC.</a:t>
-            </a:r>
-          </a:p>
-        </p:txBody>
-      </p:sp>
-      <p:sp>
-        <p:nvSpPr>
-          <p:cNvPr id="9" name="Oval 8">
-            <a:extLst>
-              <a:ext uri="{FF2B5EF4-FFF2-40B4-BE49-F238E27FC236}">
-                <a16:creationId xmlns:a16="http://schemas.microsoft.com/office/drawing/2014/main" id="{B70526C7-E931-7444-8BB7-871151D97040}"/>
-              </a:ext>
-            </a:extLst>
-          </p:cNvPr>
-          <p:cNvSpPr/>
-          <p:nvPr/>
-        </p:nvSpPr>
-        <p:spPr>
-          <a:xfrm>
-            <a:off x="9271000" y="2032000"/>
-            <a:ext cx="762000" cy="762000"/>
-          </a:xfrm>
-          <a:prstGeom prst="ellipse">
-            <a:avLst/>
-          </a:prstGeom>
-          <a:solidFill>
-            <a:srgbClr val="2A68A8"/>
-          </a:solidFill>
-          <a:ln w="19050" cap="flat" cmpd="sng" algn="ctr">
-            <a:noFill/>
-            <a:prstDash val="solid"/>
-            <a:miter lim="800000"/>
-          </a:ln>
-        </p:spPr>
-        <p:style>
-          <a:lnRef idx="2">
-            <a:schemeClr val="accent1">
-              <a:shade val="15000"/>
-            </a:schemeClr>
-          </a:lnRef>
-          <a:fillRef idx="1">
-            <a:schemeClr val="accent1"/>
-          </a:fillRef>
-          <a:effectRef idx="0">
-            <a:schemeClr val="accent1"/>
-          </a:effectRef>
-          <a:fontRef idx="minor">
-            <a:schemeClr val="lt1"/>
-          </a:fontRef>
-        </p:style>
-        <p:txBody>
-          <a:bodyPr vertOverflow="clip" horzOverflow="clip" rtlCol="0" anchor="t"/>
-          <a:lstStyle/>
-          <a:p>
-            <a:pPr algn="l"/>
-            <a:endParaRPr lang="en-US" dirty="0"/>
-          </a:p>
-        </p:txBody>
-      </p:sp>
-      <p:sp>
-        <p:nvSpPr>
-          <p:cNvPr id="10" name="TextBox 9">
-            <a:extLst>
-              <a:ext uri="{FF2B5EF4-FFF2-40B4-BE49-F238E27FC236}">
-                <a16:creationId xmlns:a16="http://schemas.microsoft.com/office/drawing/2014/main" id="{AB146947-D66A-FA40-B46D-FEA2DE14BB59}"/>
-              </a:ext>
-            </a:extLst>
-          </p:cNvPr>
-          <p:cNvSpPr txBox="1"/>
-          <p:nvPr/>
-        </p:nvSpPr>
-        <p:spPr>
-          <a:xfrm>
-            <a:off x="8001000" y="2946400"/>
-            <a:ext cx="3302000" cy="355600"/>
-          </a:xfrm>
-          <a:prstGeom prst="rect">
-            <a:avLst/>
-          </a:prstGeom>
-          <a:noFill/>
-        </p:spPr>
-        <p:txBody>
-          <a:bodyPr vertOverflow="overflow" vert="horz" wrap="square" rtlCol="0" anchor="t">
-            <a:noAutofit/>
-          </a:bodyPr>
-          <a:lstStyle/>
-          <a:p>
-            <a:pPr algn="l"/>
-            <a:r>
-              <a:rPr lang="en-US" sz="1600" b="1">
-                <a:solidFill>
-                  <a:srgbClr val="1A1A1A"/>
-                </a:solidFill>
-              </a:rPr>
-              <a:t>Lokasi Berjenjang</a:t>
-            </a:r>
-          </a:p>
-        </p:txBody>
-      </p:sp>
-      <p:sp>
-        <p:nvSpPr>
-          <p:cNvPr id="11" name="TextBox 10">
-            <a:extLst>
-              <a:ext uri="{FF2B5EF4-FFF2-40B4-BE49-F238E27FC236}">
-                <a16:creationId xmlns:a16="http://schemas.microsoft.com/office/drawing/2014/main" id="{D8A97768-C30F-FF48-91D6-56001D9D4B3A}"/>
-              </a:ext>
-            </a:extLst>
-          </p:cNvPr>
-          <p:cNvSpPr txBox="1"/>
-          <p:nvPr/>
-        </p:nvSpPr>
-        <p:spPr>
-          <a:xfrm>
-            <a:off x="8102600" y="3327400"/>
-            <a:ext cx="3098800" cy="635000"/>
-          </a:xfrm>
-          <a:prstGeom prst="rect">
-            <a:avLst/>
-          </a:prstGeom>
-          <a:noFill/>
-        </p:spPr>
-        <p:txBody>
-          <a:bodyPr vertOverflow="overflow" vert="horz" wrap="square" rtlCol="0" anchor="t">
-            <a:noAutofit/>
-          </a:bodyPr>
-          <a:lstStyle/>
-          <a:p>
-            <a:pPr algn="l"/>
-            <a:r>
-              <a:rPr lang="en-US" sz="1400">
-                <a:solidFill>
-                  <a:srgbClr val="374151"/>
-                </a:solidFill>
-              </a:rPr>
-              <a:t>Pendataan seluruh wilayah Indonesia.</a:t>
-            </a:r>
-          </a:p>
-        </p:txBody>
-      </p:sp>
-      <p:sp>
-        <p:nvSpPr>
-          <p:cNvPr id="12" name="Oval 11">
-            <a:extLst>
-              <a:ext uri="{FF2B5EF4-FFF2-40B4-BE49-F238E27FC236}">
-                <a16:creationId xmlns:a16="http://schemas.microsoft.com/office/drawing/2014/main" id="{0E6DFA05-57A7-4D4A-A9C5-8D5C2B816CAD}"/>
-              </a:ext>
-            </a:extLst>
-          </p:cNvPr>
-          <p:cNvSpPr/>
-          <p:nvPr/>
-        </p:nvSpPr>
-        <p:spPr>
-          <a:xfrm>
-            <a:off x="2159000" y="4470400"/>
-            <a:ext cx="762000" cy="762000"/>
-          </a:xfrm>
-          <a:prstGeom prst="ellipse">
-            <a:avLst/>
-          </a:prstGeom>
-          <a:solidFill>
-            <a:srgbClr val="2A68A8"/>
-          </a:solidFill>
-          <a:ln w="19050" cap="flat" cmpd="sng" algn="ctr">
-            <a:noFill/>
-            <a:prstDash val="solid"/>
-            <a:miter lim="800000"/>
-          </a:ln>
-        </p:spPr>
-        <p:style>
-          <a:lnRef idx="2">
-            <a:schemeClr val="accent1">
-              <a:shade val="15000"/>
-            </a:schemeClr>
-          </a:lnRef>
-          <a:fillRef idx="1">
-            <a:schemeClr val="accent1"/>
-          </a:fillRef>
-          <a:effectRef idx="0">
-            <a:schemeClr val="accent1"/>
-          </a:effectRef>
-          <a:fontRef idx="minor">
-            <a:schemeClr val="lt1"/>
-          </a:fontRef>
-        </p:style>
-        <p:txBody>
-          <a:bodyPr vertOverflow="clip" horzOverflow="clip" rtlCol="0" anchor="t"/>
-          <a:lstStyle/>
-          <a:p>
-            <a:pPr algn="l"/>
-            <a:endParaRPr lang="en-US" dirty="0"/>
-          </a:p>
-        </p:txBody>
-      </p:sp>
-      <p:sp>
-        <p:nvSpPr>
-          <p:cNvPr id="13" name="TextBox 12">
-            <a:extLst>
-              <a:ext uri="{FF2B5EF4-FFF2-40B4-BE49-F238E27FC236}">
-                <a16:creationId xmlns:a16="http://schemas.microsoft.com/office/drawing/2014/main" id="{D4A3340E-E817-414A-9B2B-A3D07E852DEC}"/>
-              </a:ext>
-            </a:extLst>
-          </p:cNvPr>
-          <p:cNvSpPr txBox="1"/>
-          <p:nvPr/>
-        </p:nvSpPr>
-        <p:spPr>
-          <a:xfrm>
-            <a:off x="889000" y="5384800"/>
-            <a:ext cx="3302000" cy="355600"/>
-          </a:xfrm>
-          <a:prstGeom prst="rect">
-            <a:avLst/>
-          </a:prstGeom>
-          <a:noFill/>
-        </p:spPr>
-        <p:txBody>
-          <a:bodyPr vertOverflow="overflow" vert="horz" wrap="square" rtlCol="0" anchor="t">
-            <a:noAutofit/>
-          </a:bodyPr>
-          <a:lstStyle/>
-          <a:p>
-            <a:pPr algn="l"/>
-            <a:r>
-              <a:rPr lang="en-US" sz="1600" b="1">
-                <a:solidFill>
-                  <a:srgbClr val="1A1A1A"/>
-                </a:solidFill>
-              </a:rPr>
-              <a:t>Alur Verifikasi</a:t>
-            </a:r>
-          </a:p>
-        </p:txBody>
-      </p:sp>
-      <p:sp>
-        <p:nvSpPr>
-          <p:cNvPr id="14" name="TextBox 13">
-            <a:extLst>
-              <a:ext uri="{FF2B5EF4-FFF2-40B4-BE49-F238E27FC236}">
-                <a16:creationId xmlns:a16="http://schemas.microsoft.com/office/drawing/2014/main" id="{156343F0-FB42-104B-8B88-8C8EE12028B2}"/>
-              </a:ext>
-            </a:extLst>
-          </p:cNvPr>
-          <p:cNvSpPr txBox="1"/>
-          <p:nvPr/>
-        </p:nvSpPr>
-        <p:spPr>
-          <a:xfrm>
-            <a:off x="990600" y="5765800"/>
-            <a:ext cx="3098800" cy="635000"/>
-          </a:xfrm>
-          <a:prstGeom prst="rect">
-            <a:avLst/>
-          </a:prstGeom>
-          <a:noFill/>
-        </p:spPr>
-        <p:txBody>
-          <a:bodyPr vertOverflow="overflow" vert="horz" wrap="square" rtlCol="0" anchor="t">
-            <a:noAutofit/>
-          </a:bodyPr>
-          <a:lstStyle/>
-          <a:p>
-            <a:pPr algn="l"/>
-            <a:r>
-              <a:rPr lang="en-US" sz="1400">
-                <a:solidFill>
-                  <a:srgbClr val="374151"/>
-                </a:solidFill>
-              </a:rPr>
-              <a:t>Jaminan kualitas setiap data.</a:t>
-            </a:r>
-          </a:p>
-        </p:txBody>
-      </p:sp>
-      <p:sp>
-        <p:nvSpPr>
-          <p:cNvPr id="15" name="Oval 14">
-            <a:extLst>
-              <a:ext uri="{FF2B5EF4-FFF2-40B4-BE49-F238E27FC236}">
-                <a16:creationId xmlns:a16="http://schemas.microsoft.com/office/drawing/2014/main" id="{1E6A267B-EA8F-4842-90FA-252B7EE570EC}"/>
-              </a:ext>
-            </a:extLst>
-          </p:cNvPr>
-          <p:cNvSpPr/>
-          <p:nvPr/>
-        </p:nvSpPr>
-        <p:spPr>
-          <a:xfrm>
-            <a:off x="5715000" y="4470400"/>
-            <a:ext cx="762000" cy="762000"/>
-          </a:xfrm>
-          <a:prstGeom prst="ellipse">
-            <a:avLst/>
-          </a:prstGeom>
-          <a:solidFill>
-            <a:srgbClr val="2A68A8"/>
-          </a:solidFill>
-          <a:ln w="19050" cap="flat" cmpd="sng" algn="ctr">
-            <a:noFill/>
-            <a:prstDash val="solid"/>
-            <a:miter lim="800000"/>
-          </a:ln>
-        </p:spPr>
-        <p:style>
-          <a:lnRef idx="2">
-            <a:schemeClr val="accent1">
-              <a:shade val="15000"/>
-            </a:schemeClr>
-          </a:lnRef>
-          <a:fillRef idx="1">
-            <a:schemeClr val="accent1"/>
-          </a:fillRef>
-          <a:effectRef idx="0">
-            <a:schemeClr val="accent1"/>
-          </a:effectRef>
-          <a:fontRef idx="minor">
-            <a:schemeClr val="lt1"/>
-          </a:fontRef>
-        </p:style>
-        <p:txBody>
-          <a:bodyPr vertOverflow="clip" horzOverflow="clip" rtlCol="0" anchor="t"/>
-          <a:lstStyle/>
-          <a:p>
-            <a:pPr algn="l"/>
-            <a:endParaRPr lang="en-US" dirty="0"/>
-          </a:p>
-        </p:txBody>
-      </p:sp>
-      <p:sp>
-        <p:nvSpPr>
-          <p:cNvPr id="16" name="TextBox 15">
-            <a:extLst>
-              <a:ext uri="{FF2B5EF4-FFF2-40B4-BE49-F238E27FC236}">
-                <a16:creationId xmlns:a16="http://schemas.microsoft.com/office/drawing/2014/main" id="{6837F9F0-A0C1-0146-AF9D-F4FFB5DBB088}"/>
-              </a:ext>
-            </a:extLst>
-          </p:cNvPr>
-          <p:cNvSpPr txBox="1"/>
-          <p:nvPr/>
-        </p:nvSpPr>
-        <p:spPr>
-          <a:xfrm>
-            <a:off x="4445000" y="5384800"/>
-            <a:ext cx="3302000" cy="355600"/>
-          </a:xfrm>
-          <a:prstGeom prst="rect">
-            <a:avLst/>
-          </a:prstGeom>
-          <a:noFill/>
-        </p:spPr>
-        <p:txBody>
-          <a:bodyPr vertOverflow="overflow" vert="horz" wrap="square" rtlCol="0" anchor="t">
-            <a:noAutofit/>
-          </a:bodyPr>
-          <a:lstStyle/>
-          <a:p>
-            <a:pPr algn="l"/>
-            <a:r>
-              <a:rPr lang="en-US" sz="1600" b="1">
-                <a:solidFill>
-                  <a:srgbClr val="1A1A1A"/>
-                </a:solidFill>
-              </a:rPr>
-              <a:t>Isi di Lapangan</a:t>
-            </a:r>
-          </a:p>
-        </p:txBody>
-      </p:sp>
-      <p:sp>
-        <p:nvSpPr>
-          <p:cNvPr id="17" name="TextBox 16">
-            <a:extLst>
-              <a:ext uri="{FF2B5EF4-FFF2-40B4-BE49-F238E27FC236}">
-                <a16:creationId xmlns:a16="http://schemas.microsoft.com/office/drawing/2014/main" id="{AF54EE7F-8975-A648-A965-2E665A87C310}"/>
-              </a:ext>
-            </a:extLst>
-          </p:cNvPr>
-          <p:cNvSpPr txBox="1"/>
-          <p:nvPr/>
-        </p:nvSpPr>
-        <p:spPr>
-          <a:xfrm>
-            <a:off x="4546600" y="5765800"/>
-            <a:ext cx="3098800" cy="635000"/>
-          </a:xfrm>
-          <a:prstGeom prst="rect">
-            <a:avLst/>
-          </a:prstGeom>
-          <a:noFill/>
-        </p:spPr>
-        <p:txBody>
-          <a:bodyPr vertOverflow="overflow" vert="horz" wrap="square" rtlCol="0" anchor="t">
-            <a:noAutofit/>
-          </a:bodyPr>
-          <a:lstStyle/>
-          <a:p>
-            <a:pPr algn="l"/>
-            <a:r>
-              <a:rPr lang="en-US" sz="1400">
-                <a:solidFill>
-                  <a:srgbClr val="374151"/>
-                </a:solidFill>
-              </a:rPr>
-              <a:t>Sync otomatis + unggah foto.</a:t>
-            </a:r>
-          </a:p>
-        </p:txBody>
-      </p:sp>
-      <p:sp>
-        <p:nvSpPr>
-          <p:cNvPr id="18" name="Oval 17">
-            <a:extLst>
-              <a:ext uri="{FF2B5EF4-FFF2-40B4-BE49-F238E27FC236}">
-                <a16:creationId xmlns:a16="http://schemas.microsoft.com/office/drawing/2014/main" id="{85985469-14A9-1948-BF50-D89C3F541891}"/>
-              </a:ext>
-            </a:extLst>
-          </p:cNvPr>
-          <p:cNvSpPr/>
-          <p:nvPr/>
-        </p:nvSpPr>
-        <p:spPr>
-          <a:xfrm>
-            <a:off x="9271000" y="4470400"/>
-            <a:ext cx="762000" cy="762000"/>
-          </a:xfrm>
-          <a:prstGeom prst="ellipse">
-            <a:avLst/>
-          </a:prstGeom>
-          <a:solidFill>
-            <a:srgbClr val="2A68A8"/>
-          </a:solidFill>
-          <a:ln w="19050" cap="flat" cmpd="sng" algn="ctr">
-            <a:noFill/>
-            <a:prstDash val="solid"/>
-            <a:miter lim="800000"/>
-          </a:ln>
-        </p:spPr>
-        <p:style>
-          <a:lnRef idx="2">
-            <a:schemeClr val="accent1">
-              <a:shade val="15000"/>
-            </a:schemeClr>
-          </a:lnRef>
-          <a:fillRef idx="1">
-            <a:schemeClr val="accent1"/>
-          </a:fillRef>
-          <a:effectRef idx="0">
-            <a:schemeClr val="accent1"/>
-          </a:effectRef>
-          <a:fontRef idx="minor">
-            <a:schemeClr val="lt1"/>
-          </a:fontRef>
-        </p:style>
-        <p:txBody>
-          <a:bodyPr vertOverflow="clip" horzOverflow="clip" rtlCol="0" anchor="t"/>
-          <a:lstStyle/>
-          <a:p>
-            <a:pPr algn="l"/>
-            <a:endParaRPr lang="en-US"/>
-          </a:p>
-        </p:txBody>
-      </p:sp>
-      <p:sp>
-        <p:nvSpPr>
-          <p:cNvPr id="19" name="TextBox 18">
-            <a:extLst>
-              <a:ext uri="{FF2B5EF4-FFF2-40B4-BE49-F238E27FC236}">
-                <a16:creationId xmlns:a16="http://schemas.microsoft.com/office/drawing/2014/main" id="{20932C45-F988-FD43-BE64-EC6138C4F594}"/>
-              </a:ext>
-            </a:extLst>
-          </p:cNvPr>
-          <p:cNvSpPr txBox="1"/>
-          <p:nvPr/>
-        </p:nvSpPr>
-        <p:spPr>
-          <a:xfrm>
-            <a:off x="8001000" y="5384800"/>
-            <a:ext cx="3302000" cy="355600"/>
-          </a:xfrm>
-          <a:prstGeom prst="rect">
-            <a:avLst/>
-          </a:prstGeom>
-          <a:noFill/>
-        </p:spPr>
-        <p:txBody>
-          <a:bodyPr vertOverflow="overflow" vert="horz" wrap="square" rtlCol="0" anchor="t">
-            <a:noAutofit/>
-          </a:bodyPr>
-          <a:lstStyle/>
-          <a:p>
-            <a:pPr algn="l"/>
-            <a:r>
-              <a:rPr lang="en-US" sz="1600" b="1">
-                <a:solidFill>
-                  <a:srgbClr val="1A1A1A"/>
-                </a:solidFill>
-              </a:rPr>
-              <a:t>Riwayat &amp; Audit</a:t>
-            </a:r>
-          </a:p>
-        </p:txBody>
-      </p:sp>
-      <p:sp>
-        <p:nvSpPr>
-          <p:cNvPr id="20" name="TextBox 19">
-            <a:extLst>
-              <a:ext uri="{FF2B5EF4-FFF2-40B4-BE49-F238E27FC236}">
-                <a16:creationId xmlns:a16="http://schemas.microsoft.com/office/drawing/2014/main" id="{47248E57-A557-3941-B007-21F63E521104}"/>
-              </a:ext>
-            </a:extLst>
-          </p:cNvPr>
-          <p:cNvSpPr txBox="1"/>
-          <p:nvPr/>
-        </p:nvSpPr>
-        <p:spPr>
-          <a:xfrm>
-            <a:off x="8102600" y="5765800"/>
-            <a:ext cx="3098800" cy="635000"/>
-          </a:xfrm>
-          <a:prstGeom prst="rect">
-            <a:avLst/>
-          </a:prstGeom>
-          <a:noFill/>
-        </p:spPr>
-        <p:txBody>
-          <a:bodyPr vertOverflow="overflow" vert="horz" wrap="square" rtlCol="0" anchor="t">
-            <a:noAutofit/>
-          </a:bodyPr>
-          <a:lstStyle/>
-          <a:p>
-            <a:pPr algn="l"/>
-            <a:r>
-              <a:rPr lang="en-US" sz="1400">
-                <a:solidFill>
-                  <a:srgbClr val="374151"/>
-                </a:solidFill>
-              </a:rPr>
-              <a:t>Setiap perubahan tercatat.</a:t>
-            </a:r>
-          </a:p>
-        </p:txBody>
-      </p:sp>
-      <p:pic>
-        <p:nvPicPr>
-          <p:cNvPr id="21" name="Graphic 21"/>
-          <p:cNvPicPr>
-            <a:picLocks noChangeAspect="1"/>
-          </p:cNvPicPr>
-          <p:nvPr/>
-        </p:nvPicPr>
-        <p:blipFill>
-          <a:blip>
-            <a:extLst>
-              <a:ext uri="{96DAC541-7B7A-43D3-8B79-37D633B846F1}">
-                <asvg:svgBlip xmlns:asvg="http://schemas.microsoft.com/office/drawing/2016/SVG/main" r:embed="rId2"/>
-              </a:ext>
-            </a:extLst>
-          </a:blip>
-          <a:srcRect/>
-          <a:stretch/>
-        </p:blipFill>
-        <p:spPr>
-          <a:xfrm>
-            <a:off x="2336800" y="2209800"/>
-            <a:ext cx="406400" cy="406400"/>
-          </a:xfrm>
-          <a:prstGeom prst="rect">
-            <a:avLst/>
-          </a:prstGeom>
-        </p:spPr>
-      </p:pic>
-      <p:pic>
-        <p:nvPicPr>
-          <p:cNvPr id="22" name="Graphic 22"/>
-          <p:cNvPicPr>
-            <a:picLocks noChangeAspect="1"/>
-          </p:cNvPicPr>
-          <p:nvPr/>
-        </p:nvPicPr>
-        <p:blipFill>
-          <a:blip>
-            <a:extLst>
-              <a:ext uri="{96DAC541-7B7A-43D3-8B79-37D633B846F1}">
-                <asvg:svgBlip xmlns:asvg="http://schemas.microsoft.com/office/drawing/2016/SVG/main" r:embed="rId3"/>
-              </a:ext>
-            </a:extLst>
-          </a:blip>
-          <a:srcRect/>
-          <a:stretch/>
-        </p:blipFill>
-        <p:spPr>
-          <a:xfrm>
-            <a:off x="5918200" y="2235200"/>
-            <a:ext cx="355600" cy="355600"/>
-          </a:xfrm>
-          <a:prstGeom prst="rect">
-            <a:avLst/>
-          </a:prstGeom>
-        </p:spPr>
-      </p:pic>
-      <p:pic>
-        <p:nvPicPr>
-          <p:cNvPr id="23" name="Graphic 23"/>
-          <p:cNvPicPr>
-            <a:picLocks noChangeAspect="1"/>
-          </p:cNvPicPr>
-          <p:nvPr/>
-        </p:nvPicPr>
-        <p:blipFill>
-          <a:blip>
-            <a:extLst>
-              <a:ext uri="{96DAC541-7B7A-43D3-8B79-37D633B846F1}">
-                <asvg:svgBlip xmlns:asvg="http://schemas.microsoft.com/office/drawing/2016/SVG/main" r:embed="rId4"/>
-              </a:ext>
-            </a:extLst>
-          </a:blip>
-          <a:srcRect/>
-          <a:stretch/>
-        </p:blipFill>
-        <p:spPr>
-          <a:xfrm>
-            <a:off x="9474200" y="2235200"/>
-            <a:ext cx="355600" cy="355600"/>
-          </a:xfrm>
-          <a:prstGeom prst="rect">
-            <a:avLst/>
-          </a:prstGeom>
-        </p:spPr>
-      </p:pic>
-      <p:pic>
-        <p:nvPicPr>
-          <p:cNvPr id="24" name="Graphic 24"/>
-          <p:cNvPicPr>
-            <a:picLocks noChangeAspect="1"/>
-          </p:cNvPicPr>
-          <p:nvPr/>
-        </p:nvPicPr>
-        <p:blipFill>
-          <a:blip>
-            <a:extLst>
-              <a:ext uri="{96DAC541-7B7A-43D3-8B79-37D633B846F1}">
-                <asvg:svgBlip xmlns:asvg="http://schemas.microsoft.com/office/drawing/2016/SVG/main" r:embed="rId5"/>
-              </a:ext>
-            </a:extLst>
-          </a:blip>
-          <a:srcRect/>
-          <a:stretch/>
-        </p:blipFill>
-        <p:spPr>
-          <a:xfrm>
-            <a:off x="2336800" y="4648200"/>
-            <a:ext cx="406400" cy="406400"/>
-          </a:xfrm>
-          <a:prstGeom prst="rect">
-            <a:avLst/>
-          </a:prstGeom>
-        </p:spPr>
-      </p:pic>
-      <p:pic>
-        <p:nvPicPr>
-          <p:cNvPr id="25" name="Graphic 25"/>
-          <p:cNvPicPr>
-            <a:picLocks noChangeAspect="1"/>
-          </p:cNvPicPr>
-          <p:nvPr/>
-        </p:nvPicPr>
-        <p:blipFill>
-          <a:blip>
-            <a:extLst>
-              <a:ext uri="{96DAC541-7B7A-43D3-8B79-37D633B846F1}">
-                <asvg:svgBlip xmlns:asvg="http://schemas.microsoft.com/office/drawing/2016/SVG/main" r:embed="rId6"/>
-              </a:ext>
-            </a:extLst>
-          </a:blip>
-          <a:srcRect/>
-          <a:stretch/>
-        </p:blipFill>
-        <p:spPr>
-          <a:xfrm>
-            <a:off x="5905500" y="4660900"/>
-            <a:ext cx="406400" cy="406400"/>
-          </a:xfrm>
-          <a:prstGeom prst="rect">
-            <a:avLst/>
-          </a:prstGeom>
-        </p:spPr>
-      </p:pic>
-      <p:pic>
-        <p:nvPicPr>
-          <p:cNvPr id="26" name="Graphic 26"/>
-          <p:cNvPicPr>
-            <a:picLocks noChangeAspect="1"/>
-          </p:cNvPicPr>
-          <p:nvPr/>
-        </p:nvPicPr>
-        <p:blipFill>
-          <a:blip>
-            <a:extLst>
-              <a:ext uri="{96DAC541-7B7A-43D3-8B79-37D633B846F1}">
-                <asvg:svgBlip xmlns:asvg="http://schemas.microsoft.com/office/drawing/2016/SVG/main" r:embed="rId7"/>
-              </a:ext>
-            </a:extLst>
-          </a:blip>
-          <a:srcRect/>
-          <a:stretch/>
-        </p:blipFill>
-        <p:spPr>
-          <a:xfrm>
-            <a:off x="9474200" y="4648200"/>
-            <a:ext cx="406400" cy="406400"/>
-          </a:xfrm>
-          <a:prstGeom prst="rect">
-            <a:avLst/>
-          </a:prstGeom>
-        </p:spPr>
-      </p:pic>
-    </p:spTree>
-    <p:extLst>
-      <p:ext uri="{BB962C8B-B14F-4D97-AF65-F5344CB8AC3E}">
-        <p14:creationId xmlns:p14="http://schemas.microsoft.com/office/powerpoint/2010/main" val="3923697559"/>
-      </p:ext>
-    </p:extLst>
-  </p:cSld>
-  <p:clrMapOvr>
-    <a:masterClrMapping/>
-  </p:clrMapOvr>
-</p:sld>
-</file>
-
-<file path=ppt/slides/slide11.xml><?xml version="1.0" encoding="utf-8"?>
-<p:sld xmlns:a="http://schemas.openxmlformats.org/drawingml/2006/main" xmlns:r="http://schemas.openxmlformats.org/officeDocument/2006/relationships" xmlns:p="http://schemas.openxmlformats.org/presentationml/2006/main">
-  <p:cSld>
-    <p:spTree>
-      <p:nvGrpSpPr>
-        <p:cNvPr id="1" name=""/>
-        <p:cNvGrpSpPr/>
-        <p:nvPr/>
-      </p:nvGrpSpPr>
-      <p:grpSpPr>
-        <a:xfrm>
-          <a:off x="0" y="0"/>
-          <a:ext cx="0" cy="0"/>
-          <a:chOff x="0" y="0"/>
-          <a:chExt cx="0" cy="0"/>
-        </a:xfrm>
-      </p:grpSpPr>
-      <p:sp>
-        <p:nvSpPr>
-          <p:cNvPr id="2" name="Title 1">
-            <a:extLst>
-              <a:ext uri="{FF2B5EF4-FFF2-40B4-BE49-F238E27FC236}">
                 <a16:creationId xmlns:a16="http://schemas.microsoft.com/office/drawing/2014/main" id="{EB25CDB3-1FEF-0E34-166D-E5A9C4776979}"/>
               </a:ext>
             </a:extLst>
@@ -7126,7 +6005,7 @@
 </p:sld>
 </file>
 
-<file path=ppt/slides/slide12.xml><?xml version="1.0" encoding="utf-8"?>
+<file path=ppt/slides/slide11.xml><?xml version="1.0" encoding="utf-8"?>
 <p:sld xmlns:a="http://schemas.openxmlformats.org/drawingml/2006/main" xmlns:r="http://schemas.openxmlformats.org/officeDocument/2006/relationships" xmlns:p="http://schemas.openxmlformats.org/presentationml/2006/main">
   <p:cSld>
     <p:bg>
@@ -8285,12 +7164,100 @@
           <a:p>
             <a:pPr algn="l"/>
             <a:r>
-              <a:rPr lang="en-US" sz="1500">
+              <a:rPr lang="en-US" sz="1500" dirty="0" err="1">
                 <a:solidFill>
                   <a:srgbClr val="374151"/>
                 </a:solidFill>
               </a:rPr>
-              <a:t>Memeriksa serta menyetujui atau menolak data yang masuk.</a:t>
+              <a:t>Memeriksa</a:t>
+            </a:r>
+            <a:r>
+              <a:rPr lang="en-US" sz="1500" dirty="0">
+                <a:solidFill>
+                  <a:srgbClr val="374151"/>
+                </a:solidFill>
+              </a:rPr>
+              <a:t> </a:t>
+            </a:r>
+            <a:r>
+              <a:rPr lang="en-US" sz="1500" dirty="0" err="1">
+                <a:solidFill>
+                  <a:srgbClr val="374151"/>
+                </a:solidFill>
+              </a:rPr>
+              <a:t>serta</a:t>
+            </a:r>
+            <a:r>
+              <a:rPr lang="en-US" sz="1500" dirty="0">
+                <a:solidFill>
+                  <a:srgbClr val="374151"/>
+                </a:solidFill>
+              </a:rPr>
+              <a:t> </a:t>
+            </a:r>
+            <a:r>
+              <a:rPr lang="en-US" sz="1500" dirty="0" err="1">
+                <a:solidFill>
+                  <a:srgbClr val="374151"/>
+                </a:solidFill>
+              </a:rPr>
+              <a:t>menyetujui</a:t>
+            </a:r>
+            <a:r>
+              <a:rPr lang="en-US" sz="1500" dirty="0">
+                <a:solidFill>
+                  <a:srgbClr val="374151"/>
+                </a:solidFill>
+              </a:rPr>
+              <a:t> </a:t>
+            </a:r>
+            <a:r>
+              <a:rPr lang="en-US" sz="1500" dirty="0" err="1">
+                <a:solidFill>
+                  <a:srgbClr val="374151"/>
+                </a:solidFill>
+              </a:rPr>
+              <a:t>atau</a:t>
+            </a:r>
+            <a:r>
+              <a:rPr lang="en-US" sz="1500" dirty="0">
+                <a:solidFill>
+                  <a:srgbClr val="374151"/>
+                </a:solidFill>
+              </a:rPr>
+              <a:t> </a:t>
+            </a:r>
+            <a:r>
+              <a:rPr lang="en-US" sz="1500" dirty="0" err="1">
+                <a:solidFill>
+                  <a:srgbClr val="374151"/>
+                </a:solidFill>
+              </a:rPr>
+              <a:t>menolak</a:t>
+            </a:r>
+            <a:r>
+              <a:rPr lang="en-US" sz="1500" dirty="0">
+                <a:solidFill>
+                  <a:srgbClr val="374151"/>
+                </a:solidFill>
+              </a:rPr>
+              <a:t> data yang </a:t>
+            </a:r>
+            <a:r>
+              <a:rPr lang="en-US" sz="1500" dirty="0" err="1">
+                <a:solidFill>
+                  <a:srgbClr val="374151"/>
+                </a:solidFill>
+              </a:rPr>
+              <a:t>masuk</a:t>
+            </a:r>
+            <a:r>
+              <a:rPr lang="en-US" sz="1500" dirty="0">
+                <a:solidFill>
+                  <a:srgbClr val="374151"/>
+                </a:solidFill>
+              </a:rPr>
+              <a:t>.</a:t>
             </a:r>
           </a:p>
         </p:txBody>
@@ -14528,7 +13495,7 @@
           <p:cNvPr id="2" name="Title 1">
             <a:extLst>
               <a:ext uri="{FF2B5EF4-FFF2-40B4-BE49-F238E27FC236}">
-                <a16:creationId xmlns:a16="http://schemas.microsoft.com/office/drawing/2014/main" id="{0BC3521E-AA99-8973-B246-13896D1B1539}"/>
+                <a16:creationId xmlns:a16="http://schemas.microsoft.com/office/drawing/2014/main" id="{957AFCFC-0AB1-ACF3-1CDC-BF09E9C23D47}"/>
               </a:ext>
             </a:extLst>
           </p:cNvPr>
@@ -14541,24 +13508,22 @@
         </p:nvSpPr>
         <p:spPr/>
         <p:txBody>
-          <a:bodyPr>
-            <a:normAutofit/>
-          </a:bodyPr>
-          <a:lstStyle/>
-          <a:p>
-            <a:r>
-              <a:rPr lang="en-US" sz="2600"/>
-              <a:t>Cara Pakai — Verifikator &amp; Admin (Dashboard Web)</a:t>
-            </a:r>
-          </a:p>
-        </p:txBody>
-      </p:sp>
-      <p:sp>
-        <p:nvSpPr>
-          <p:cNvPr id="3" name="Rounded Rectangle 2">
-            <a:extLst>
-              <a:ext uri="{FF2B5EF4-FFF2-40B4-BE49-F238E27FC236}">
-                <a16:creationId xmlns:a16="http://schemas.microsoft.com/office/drawing/2014/main" id="{D5E16CFD-385C-4241-88E6-381F0FCDA5BB}"/>
+          <a:bodyPr/>
+          <a:lstStyle/>
+          <a:p>
+            <a:r>
+              <a:rPr lang="en-US"/>
+              <a:t>Fitur Unggulan</a:t>
+            </a:r>
+          </a:p>
+        </p:txBody>
+      </p:sp>
+      <p:sp>
+        <p:nvSpPr>
+          <p:cNvPr id="3" name="Oval 2">
+            <a:extLst>
+              <a:ext uri="{FF2B5EF4-FFF2-40B4-BE49-F238E27FC236}">
+                <a16:creationId xmlns:a16="http://schemas.microsoft.com/office/drawing/2014/main" id="{5C241E56-2D47-5543-8C48-FC7EB49164DB}"/>
               </a:ext>
             </a:extLst>
           </p:cNvPr>
@@ -14567,64 +13532,8 @@
         </p:nvSpPr>
         <p:spPr>
           <a:xfrm>
-            <a:off x="762000" y="1905000"/>
-            <a:ext cx="10668000" cy="685800"/>
-          </a:xfrm>
-          <a:prstGeom prst="roundRect">
-            <a:avLst/>
-          </a:prstGeom>
-          <a:solidFill>
-            <a:srgbClr val="F5F7F7"/>
-          </a:solidFill>
-          <a:ln w="12700" cap="flat" cmpd="sng" algn="ctr">
-            <a:solidFill>
-              <a:srgbClr val="E5E7EB"/>
-            </a:solidFill>
-            <a:prstDash val="solid"/>
-            <a:miter lim="800000"/>
-          </a:ln>
-        </p:spPr>
-        <p:style>
-          <a:lnRef idx="2">
-            <a:schemeClr val="accent1">
-              <a:shade val="15000"/>
-            </a:schemeClr>
-          </a:lnRef>
-          <a:fillRef idx="1">
-            <a:schemeClr val="accent1"/>
-          </a:fillRef>
-          <a:effectRef idx="0">
-            <a:schemeClr val="accent1"/>
-          </a:effectRef>
-          <a:fontRef idx="minor">
-            <a:schemeClr val="lt1"/>
-          </a:fontRef>
-        </p:style>
-        <p:txBody>
-          <a:bodyPr vertOverflow="clip" horzOverflow="clip" rtlCol="0" anchor="t"/>
-          <a:lstStyle/>
-          <a:p>
-            <a:pPr algn="l"/>
-            <a:endParaRPr lang="en-US"/>
-          </a:p>
-        </p:txBody>
-      </p:sp>
-      <p:sp>
-        <p:nvSpPr>
-          <p:cNvPr id="4" name="Oval 3">
-            <a:extLst>
-              <a:ext uri="{FF2B5EF4-FFF2-40B4-BE49-F238E27FC236}">
-                <a16:creationId xmlns:a16="http://schemas.microsoft.com/office/drawing/2014/main" id="{000A092B-F195-1A41-8D86-796D8F9CCBFD}"/>
-              </a:ext>
-            </a:extLst>
-          </p:cNvPr>
-          <p:cNvSpPr/>
-          <p:nvPr/>
-        </p:nvSpPr>
-        <p:spPr>
-          <a:xfrm>
-            <a:off x="914400" y="2006600"/>
-            <a:ext cx="482600" cy="482600"/>
+            <a:off x="2159000" y="2032000"/>
+            <a:ext cx="762000" cy="762000"/>
           </a:xfrm>
           <a:prstGeom prst="ellipse">
             <a:avLst/>
@@ -14655,19 +13564,50 @@
           </a:fontRef>
         </p:style>
         <p:txBody>
-          <a:bodyPr vertOverflow="clip" horzOverflow="clip" wrap="none" rtlCol="0" anchor="ctr" anchorCtr="0">
+          <a:bodyPr vertOverflow="clip" horzOverflow="clip" rtlCol="0" anchor="t"/>
+          <a:lstStyle/>
+          <a:p>
+            <a:pPr algn="l"/>
+            <a:endParaRPr lang="en-US"/>
+          </a:p>
+        </p:txBody>
+      </p:sp>
+      <p:sp>
+        <p:nvSpPr>
+          <p:cNvPr id="4" name="TextBox 3">
+            <a:extLst>
+              <a:ext uri="{FF2B5EF4-FFF2-40B4-BE49-F238E27FC236}">
+                <a16:creationId xmlns:a16="http://schemas.microsoft.com/office/drawing/2014/main" id="{AA86062D-5C5C-434F-9569-05CBD38084CE}"/>
+              </a:ext>
+            </a:extLst>
+          </p:cNvPr>
+          <p:cNvSpPr txBox="1"/>
+          <p:nvPr/>
+        </p:nvSpPr>
+        <p:spPr>
+          <a:xfrm>
+            <a:off x="889000" y="2946400"/>
+            <a:ext cx="3302000" cy="355600"/>
+          </a:xfrm>
+          <a:prstGeom prst="rect">
+            <a:avLst/>
+          </a:prstGeom>
+          <a:noFill/>
+        </p:spPr>
+        <p:txBody>
+          <a:bodyPr vertOverflow="overflow" vert="horz" wrap="square" rtlCol="0" anchor="t">
             <a:noAutofit/>
           </a:bodyPr>
           <a:lstStyle/>
           <a:p>
             <a:pPr algn="l"/>
             <a:r>
-              <a:rPr lang="en-US" sz="1700" b="1">
-                <a:solidFill>
-                  <a:srgbClr val="FFFFFF"/>
+              <a:rPr lang="en-US" sz="1600" b="1">
+                <a:solidFill>
+                  <a:srgbClr val="1A1A1A"/>
                 </a:solidFill>
               </a:rPr>
-              <a:t>1</a:t>
+              <a:t>Form Pintar Bercabang</a:t>
             </a:r>
           </a:p>
         </p:txBody>
@@ -14677,7 +13617,7 @@
           <p:cNvPr id="5" name="TextBox 4">
             <a:extLst>
               <a:ext uri="{FF2B5EF4-FFF2-40B4-BE49-F238E27FC236}">
-                <a16:creationId xmlns:a16="http://schemas.microsoft.com/office/drawing/2014/main" id="{0D201FED-8747-EB47-8CDA-450017072291}"/>
+                <a16:creationId xmlns:a16="http://schemas.microsoft.com/office/drawing/2014/main" id="{319BCBF9-539A-5843-B3B0-238DF24A27F7}"/>
               </a:ext>
             </a:extLst>
           </p:cNvPr>
@@ -14686,8 +13626,8 @@
         </p:nvSpPr>
         <p:spPr>
           <a:xfrm>
-            <a:off x="1600200" y="1905000"/>
-            <a:ext cx="2921000" cy="685800"/>
+            <a:off x="990600" y="3327400"/>
+            <a:ext cx="3098800" cy="635000"/>
           </a:xfrm>
           <a:prstGeom prst="rect">
             <a:avLst/>
@@ -14695,69 +13635,29 @@
           <a:noFill/>
         </p:spPr>
         <p:txBody>
-          <a:bodyPr vertOverflow="overflow" vert="horz" wrap="none" rtlCol="0" anchor="ctr" anchorCtr="0">
+          <a:bodyPr vertOverflow="overflow" vert="horz" wrap="square" rtlCol="0" anchor="t">
             <a:noAutofit/>
           </a:bodyPr>
           <a:lstStyle/>
           <a:p>
             <a:pPr algn="l"/>
             <a:r>
-              <a:rPr lang="en-US" sz="1600" b="1">
-                <a:solidFill>
-                  <a:srgbClr val="2A68A8"/>
+              <a:rPr lang="en-US" sz="1400">
+                <a:solidFill>
+                  <a:srgbClr val="374151"/>
                 </a:solidFill>
               </a:rPr>
-              <a:t>Login</a:t>
-            </a:r>
-          </a:p>
-        </p:txBody>
-      </p:sp>
-      <p:sp>
-        <p:nvSpPr>
-          <p:cNvPr id="6" name="TextBox 5">
-            <a:extLst>
-              <a:ext uri="{FF2B5EF4-FFF2-40B4-BE49-F238E27FC236}">
-                <a16:creationId xmlns:a16="http://schemas.microsoft.com/office/drawing/2014/main" id="{B498DB38-F928-C845-B2B4-DECFE83CE00F}"/>
-              </a:ext>
-            </a:extLst>
-          </p:cNvPr>
-          <p:cNvSpPr txBox="1"/>
-          <p:nvPr/>
-        </p:nvSpPr>
-        <p:spPr>
-          <a:xfrm>
-            <a:off x="4699000" y="1905000"/>
-            <a:ext cx="6477000" cy="685800"/>
-          </a:xfrm>
-          <a:prstGeom prst="rect">
-            <a:avLst/>
-          </a:prstGeom>
-          <a:noFill/>
-        </p:spPr>
-        <p:txBody>
-          <a:bodyPr vertOverflow="overflow" vert="horz" wrap="square" rtlCol="0" anchor="ctr" anchorCtr="0">
-            <a:noAutofit/>
-          </a:bodyPr>
-          <a:lstStyle/>
-          <a:p>
-            <a:pPr algn="l"/>
-            <a:r>
-              <a:rPr lang="en-US" sz="1500">
-                <a:solidFill>
-                  <a:srgbClr val="374151"/>
-                </a:solidFill>
-              </a:rPr>
-              <a:t>Masuk ke dashboard web.</a:t>
-            </a:r>
-          </a:p>
-        </p:txBody>
-      </p:sp>
-      <p:sp>
-        <p:nvSpPr>
-          <p:cNvPr id="7" name="Rounded Rectangle 6">
-            <a:extLst>
-              <a:ext uri="{FF2B5EF4-FFF2-40B4-BE49-F238E27FC236}">
-                <a16:creationId xmlns:a16="http://schemas.microsoft.com/office/drawing/2014/main" id="{CE1FC8E7-FCA8-4B41-B329-85BD841392A7}"/>
+              <a:t>Hemat waktu surveyor di lapangan.</a:t>
+            </a:r>
+          </a:p>
+        </p:txBody>
+      </p:sp>
+      <p:sp>
+        <p:nvSpPr>
+          <p:cNvPr id="6" name="Oval 5">
+            <a:extLst>
+              <a:ext uri="{FF2B5EF4-FFF2-40B4-BE49-F238E27FC236}">
+                <a16:creationId xmlns:a16="http://schemas.microsoft.com/office/drawing/2014/main" id="{D46F3AE5-4C89-834F-86E2-CEFC39F4DD48}"/>
               </a:ext>
             </a:extLst>
           </p:cNvPr>
@@ -14766,64 +13666,8 @@
         </p:nvSpPr>
         <p:spPr>
           <a:xfrm>
-            <a:off x="762000" y="2679700"/>
-            <a:ext cx="10668000" cy="685800"/>
-          </a:xfrm>
-          <a:prstGeom prst="roundRect">
-            <a:avLst/>
-          </a:prstGeom>
-          <a:solidFill>
-            <a:srgbClr val="FFFFFF"/>
-          </a:solidFill>
-          <a:ln w="12700" cap="flat" cmpd="sng" algn="ctr">
-            <a:solidFill>
-              <a:srgbClr val="E5E7EB"/>
-            </a:solidFill>
-            <a:prstDash val="solid"/>
-            <a:miter lim="800000"/>
-          </a:ln>
-        </p:spPr>
-        <p:style>
-          <a:lnRef idx="2">
-            <a:schemeClr val="accent1">
-              <a:shade val="15000"/>
-            </a:schemeClr>
-          </a:lnRef>
-          <a:fillRef idx="1">
-            <a:schemeClr val="accent1"/>
-          </a:fillRef>
-          <a:effectRef idx="0">
-            <a:schemeClr val="accent1"/>
-          </a:effectRef>
-          <a:fontRef idx="minor">
-            <a:schemeClr val="lt1"/>
-          </a:fontRef>
-        </p:style>
-        <p:txBody>
-          <a:bodyPr vertOverflow="clip" horzOverflow="clip" rtlCol="0" anchor="t"/>
-          <a:lstStyle/>
-          <a:p>
-            <a:pPr algn="l"/>
-            <a:endParaRPr lang="en-US"/>
-          </a:p>
-        </p:txBody>
-      </p:sp>
-      <p:sp>
-        <p:nvSpPr>
-          <p:cNvPr id="8" name="Oval 7">
-            <a:extLst>
-              <a:ext uri="{FF2B5EF4-FFF2-40B4-BE49-F238E27FC236}">
-                <a16:creationId xmlns:a16="http://schemas.microsoft.com/office/drawing/2014/main" id="{5FD6A01D-1548-2243-A4A4-A9825EE9C4E2}"/>
-              </a:ext>
-            </a:extLst>
-          </p:cNvPr>
-          <p:cNvSpPr/>
-          <p:nvPr/>
-        </p:nvSpPr>
-        <p:spPr>
-          <a:xfrm>
-            <a:off x="914400" y="2781300"/>
-            <a:ext cx="482600" cy="482600"/>
+            <a:off x="5715000" y="2032000"/>
+            <a:ext cx="762000" cy="762000"/>
           </a:xfrm>
           <a:prstGeom prst="ellipse">
             <a:avLst/>
@@ -14854,29 +13698,60 @@
           </a:fontRef>
         </p:style>
         <p:txBody>
-          <a:bodyPr vertOverflow="clip" horzOverflow="clip" wrap="none" rtlCol="0" anchor="ctr" anchorCtr="0">
+          <a:bodyPr vertOverflow="clip" horzOverflow="clip" rtlCol="0" anchor="t"/>
+          <a:lstStyle/>
+          <a:p>
+            <a:pPr algn="l"/>
+            <a:endParaRPr lang="en-US"/>
+          </a:p>
+        </p:txBody>
+      </p:sp>
+      <p:sp>
+        <p:nvSpPr>
+          <p:cNvPr id="7" name="TextBox 6">
+            <a:extLst>
+              <a:ext uri="{FF2B5EF4-FFF2-40B4-BE49-F238E27FC236}">
+                <a16:creationId xmlns:a16="http://schemas.microsoft.com/office/drawing/2014/main" id="{3344083B-EDB2-3A42-A1D2-E7235593BA31}"/>
+              </a:ext>
+            </a:extLst>
+          </p:cNvPr>
+          <p:cNvSpPr txBox="1"/>
+          <p:nvPr/>
+        </p:nvSpPr>
+        <p:spPr>
+          <a:xfrm>
+            <a:off x="4445000" y="2946400"/>
+            <a:ext cx="3302000" cy="355600"/>
+          </a:xfrm>
+          <a:prstGeom prst="rect">
+            <a:avLst/>
+          </a:prstGeom>
+          <a:noFill/>
+        </p:spPr>
+        <p:txBody>
+          <a:bodyPr vertOverflow="overflow" vert="horz" wrap="square" rtlCol="0" anchor="t">
             <a:noAutofit/>
           </a:bodyPr>
           <a:lstStyle/>
           <a:p>
             <a:pPr algn="l"/>
             <a:r>
-              <a:rPr lang="en-US" sz="1700" b="1">
-                <a:solidFill>
-                  <a:srgbClr val="FFFFFF"/>
+              <a:rPr lang="en-US" sz="1600" b="1">
+                <a:solidFill>
+                  <a:srgbClr val="1A1A1A"/>
                 </a:solidFill>
               </a:rPr>
-              <a:t>2</a:t>
-            </a:r>
-          </a:p>
-        </p:txBody>
-      </p:sp>
-      <p:sp>
-        <p:nvSpPr>
-          <p:cNvPr id="9" name="TextBox 8">
-            <a:extLst>
-              <a:ext uri="{FF2B5EF4-FFF2-40B4-BE49-F238E27FC236}">
-                <a16:creationId xmlns:a16="http://schemas.microsoft.com/office/drawing/2014/main" id="{50C1E446-6508-2945-A062-46FD01EEB395}"/>
+              <a:t>Klasifikasi Otomatis</a:t>
+            </a:r>
+          </a:p>
+        </p:txBody>
+      </p:sp>
+      <p:sp>
+        <p:nvSpPr>
+          <p:cNvPr id="8" name="TextBox 7">
+            <a:extLst>
+              <a:ext uri="{FF2B5EF4-FFF2-40B4-BE49-F238E27FC236}">
+                <a16:creationId xmlns:a16="http://schemas.microsoft.com/office/drawing/2014/main" id="{F13BDB47-C124-EA45-BF66-86525646CE44}"/>
               </a:ext>
             </a:extLst>
           </p:cNvPr>
@@ -14885,8 +13760,8 @@
         </p:nvSpPr>
         <p:spPr>
           <a:xfrm>
-            <a:off x="1600200" y="2679700"/>
-            <a:ext cx="2921000" cy="685800"/>
+            <a:off x="4546600" y="3327400"/>
+            <a:ext cx="3098800" cy="635000"/>
           </a:xfrm>
           <a:prstGeom prst="rect">
             <a:avLst/>
@@ -14894,69 +13769,29 @@
           <a:noFill/>
         </p:spPr>
         <p:txBody>
-          <a:bodyPr vertOverflow="overflow" vert="horz" wrap="none" rtlCol="0" anchor="ctr" anchorCtr="0">
+          <a:bodyPr vertOverflow="overflow" vert="horz" wrap="square" rtlCol="0" anchor="t">
             <a:noAutofit/>
           </a:bodyPr>
           <a:lstStyle/>
           <a:p>
             <a:pPr algn="l"/>
             <a:r>
-              <a:rPr lang="en-US" sz="1600" b="1">
-                <a:solidFill>
-                  <a:srgbClr val="2A68A8"/>
+              <a:rPr lang="en-US" sz="1400">
+                <a:solidFill>
+                  <a:srgbClr val="374151"/>
                 </a:solidFill>
               </a:rPr>
-              <a:t>Antrian Verifikasi</a:t>
-            </a:r>
-          </a:p>
-        </p:txBody>
-      </p:sp>
-      <p:sp>
-        <p:nvSpPr>
-          <p:cNvPr id="10" name="TextBox 9">
-            <a:extLst>
-              <a:ext uri="{FF2B5EF4-FFF2-40B4-BE49-F238E27FC236}">
-                <a16:creationId xmlns:a16="http://schemas.microsoft.com/office/drawing/2014/main" id="{53CB2A15-22F7-D942-BD10-2FF0F08E398D}"/>
-              </a:ext>
-            </a:extLst>
-          </p:cNvPr>
-          <p:cNvSpPr txBox="1"/>
-          <p:nvPr/>
-        </p:nvSpPr>
-        <p:spPr>
-          <a:xfrm>
-            <a:off x="4699000" y="2679700"/>
-            <a:ext cx="6477000" cy="685800"/>
-          </a:xfrm>
-          <a:prstGeom prst="rect">
-            <a:avLst/>
-          </a:prstGeom>
-          <a:noFill/>
-        </p:spPr>
-        <p:txBody>
-          <a:bodyPr vertOverflow="overflow" vert="horz" wrap="square" rtlCol="0" anchor="ctr" anchorCtr="0">
-            <a:noAutofit/>
-          </a:bodyPr>
-          <a:lstStyle/>
-          <a:p>
-            <a:pPr algn="l"/>
-            <a:r>
-              <a:rPr lang="en-US" sz="1500">
-                <a:solidFill>
-                  <a:srgbClr val="374151"/>
-                </a:solidFill>
-              </a:rPr>
-              <a:t>Buka daftar survey yang masuk.</a:t>
-            </a:r>
-          </a:p>
-        </p:txBody>
-      </p:sp>
-      <p:sp>
-        <p:nvSpPr>
-          <p:cNvPr id="11" name="Rounded Rectangle 10">
-            <a:extLst>
-              <a:ext uri="{FF2B5EF4-FFF2-40B4-BE49-F238E27FC236}">
-                <a16:creationId xmlns:a16="http://schemas.microsoft.com/office/drawing/2014/main" id="{F9AB696B-775E-DA4F-BCC3-F14C9E3A77B8}"/>
+              <a:t>Mengikuti standar DESDE-LTC.</a:t>
+            </a:r>
+          </a:p>
+        </p:txBody>
+      </p:sp>
+      <p:sp>
+        <p:nvSpPr>
+          <p:cNvPr id="9" name="Oval 8">
+            <a:extLst>
+              <a:ext uri="{FF2B5EF4-FFF2-40B4-BE49-F238E27FC236}">
+                <a16:creationId xmlns:a16="http://schemas.microsoft.com/office/drawing/2014/main" id="{B70526C7-E931-7444-8BB7-871151D97040}"/>
               </a:ext>
             </a:extLst>
           </p:cNvPr>
@@ -14965,64 +13800,8 @@
         </p:nvSpPr>
         <p:spPr>
           <a:xfrm>
-            <a:off x="762000" y="3454400"/>
-            <a:ext cx="10668000" cy="685800"/>
-          </a:xfrm>
-          <a:prstGeom prst="roundRect">
-            <a:avLst/>
-          </a:prstGeom>
-          <a:solidFill>
-            <a:srgbClr val="F5F7F7"/>
-          </a:solidFill>
-          <a:ln w="12700" cap="flat" cmpd="sng" algn="ctr">
-            <a:solidFill>
-              <a:srgbClr val="E5E7EB"/>
-            </a:solidFill>
-            <a:prstDash val="solid"/>
-            <a:miter lim="800000"/>
-          </a:ln>
-        </p:spPr>
-        <p:style>
-          <a:lnRef idx="2">
-            <a:schemeClr val="accent1">
-              <a:shade val="15000"/>
-            </a:schemeClr>
-          </a:lnRef>
-          <a:fillRef idx="1">
-            <a:schemeClr val="accent1"/>
-          </a:fillRef>
-          <a:effectRef idx="0">
-            <a:schemeClr val="accent1"/>
-          </a:effectRef>
-          <a:fontRef idx="minor">
-            <a:schemeClr val="lt1"/>
-          </a:fontRef>
-        </p:style>
-        <p:txBody>
-          <a:bodyPr vertOverflow="clip" horzOverflow="clip" rtlCol="0" anchor="t"/>
-          <a:lstStyle/>
-          <a:p>
-            <a:pPr algn="l"/>
-            <a:endParaRPr lang="en-US"/>
-          </a:p>
-        </p:txBody>
-      </p:sp>
-      <p:sp>
-        <p:nvSpPr>
-          <p:cNvPr id="12" name="Oval 11">
-            <a:extLst>
-              <a:ext uri="{FF2B5EF4-FFF2-40B4-BE49-F238E27FC236}">
-                <a16:creationId xmlns:a16="http://schemas.microsoft.com/office/drawing/2014/main" id="{F6429588-B25A-F148-9A9B-0F8A789AF998}"/>
-              </a:ext>
-            </a:extLst>
-          </p:cNvPr>
-          <p:cNvSpPr/>
-          <p:nvPr/>
-        </p:nvSpPr>
-        <p:spPr>
-          <a:xfrm>
-            <a:off x="914400" y="3556000"/>
-            <a:ext cx="482600" cy="482600"/>
+            <a:off x="9271000" y="2032000"/>
+            <a:ext cx="762000" cy="762000"/>
           </a:xfrm>
           <a:prstGeom prst="ellipse">
             <a:avLst/>
@@ -15053,29 +13832,60 @@
           </a:fontRef>
         </p:style>
         <p:txBody>
-          <a:bodyPr vertOverflow="clip" horzOverflow="clip" wrap="none" rtlCol="0" anchor="ctr" anchorCtr="0">
+          <a:bodyPr vertOverflow="clip" horzOverflow="clip" rtlCol="0" anchor="t"/>
+          <a:lstStyle/>
+          <a:p>
+            <a:pPr algn="l"/>
+            <a:endParaRPr lang="en-US" dirty="0"/>
+          </a:p>
+        </p:txBody>
+      </p:sp>
+      <p:sp>
+        <p:nvSpPr>
+          <p:cNvPr id="10" name="TextBox 9">
+            <a:extLst>
+              <a:ext uri="{FF2B5EF4-FFF2-40B4-BE49-F238E27FC236}">
+                <a16:creationId xmlns:a16="http://schemas.microsoft.com/office/drawing/2014/main" id="{AB146947-D66A-FA40-B46D-FEA2DE14BB59}"/>
+              </a:ext>
+            </a:extLst>
+          </p:cNvPr>
+          <p:cNvSpPr txBox="1"/>
+          <p:nvPr/>
+        </p:nvSpPr>
+        <p:spPr>
+          <a:xfrm>
+            <a:off x="8001000" y="2946400"/>
+            <a:ext cx="3302000" cy="355600"/>
+          </a:xfrm>
+          <a:prstGeom prst="rect">
+            <a:avLst/>
+          </a:prstGeom>
+          <a:noFill/>
+        </p:spPr>
+        <p:txBody>
+          <a:bodyPr vertOverflow="overflow" vert="horz" wrap="square" rtlCol="0" anchor="t">
             <a:noAutofit/>
           </a:bodyPr>
           <a:lstStyle/>
           <a:p>
             <a:pPr algn="l"/>
             <a:r>
-              <a:rPr lang="en-US" sz="1700" b="1">
-                <a:solidFill>
-                  <a:srgbClr val="FFFFFF"/>
+              <a:rPr lang="en-US" sz="1600" b="1">
+                <a:solidFill>
+                  <a:srgbClr val="1A1A1A"/>
                 </a:solidFill>
               </a:rPr>
-              <a:t>3</a:t>
-            </a:r>
-          </a:p>
-        </p:txBody>
-      </p:sp>
-      <p:sp>
-        <p:nvSpPr>
-          <p:cNvPr id="13" name="TextBox 12">
-            <a:extLst>
-              <a:ext uri="{FF2B5EF4-FFF2-40B4-BE49-F238E27FC236}">
-                <a16:creationId xmlns:a16="http://schemas.microsoft.com/office/drawing/2014/main" id="{2EFDFC78-B400-2D4C-B0FC-2F3795AAA526}"/>
+              <a:t>Lokasi Berjenjang</a:t>
+            </a:r>
+          </a:p>
+        </p:txBody>
+      </p:sp>
+      <p:sp>
+        <p:nvSpPr>
+          <p:cNvPr id="11" name="TextBox 10">
+            <a:extLst>
+              <a:ext uri="{FF2B5EF4-FFF2-40B4-BE49-F238E27FC236}">
+                <a16:creationId xmlns:a16="http://schemas.microsoft.com/office/drawing/2014/main" id="{D8A97768-C30F-FF48-91D6-56001D9D4B3A}"/>
               </a:ext>
             </a:extLst>
           </p:cNvPr>
@@ -15084,8 +13894,8 @@
         </p:nvSpPr>
         <p:spPr>
           <a:xfrm>
-            <a:off x="1600200" y="3454400"/>
-            <a:ext cx="2921000" cy="685800"/>
+            <a:off x="8102600" y="3327400"/>
+            <a:ext cx="3098800" cy="635000"/>
           </a:xfrm>
           <a:prstGeom prst="rect">
             <a:avLst/>
@@ -15093,69 +13903,29 @@
           <a:noFill/>
         </p:spPr>
         <p:txBody>
-          <a:bodyPr vertOverflow="overflow" vert="horz" wrap="none" rtlCol="0" anchor="ctr" anchorCtr="0">
+          <a:bodyPr vertOverflow="overflow" vert="horz" wrap="square" rtlCol="0" anchor="t">
             <a:noAutofit/>
           </a:bodyPr>
           <a:lstStyle/>
           <a:p>
             <a:pPr algn="l"/>
             <a:r>
-              <a:rPr lang="en-US" sz="1600" b="1">
-                <a:solidFill>
-                  <a:srgbClr val="2A68A8"/>
+              <a:rPr lang="en-US" sz="1400">
+                <a:solidFill>
+                  <a:srgbClr val="374151"/>
                 </a:solidFill>
               </a:rPr>
-              <a:t>Periksa Detail</a:t>
-            </a:r>
-          </a:p>
-        </p:txBody>
-      </p:sp>
-      <p:sp>
-        <p:nvSpPr>
-          <p:cNvPr id="14" name="TextBox 13">
-            <a:extLst>
-              <a:ext uri="{FF2B5EF4-FFF2-40B4-BE49-F238E27FC236}">
-                <a16:creationId xmlns:a16="http://schemas.microsoft.com/office/drawing/2014/main" id="{6B8D65EB-512E-E243-B42B-5624E6EF15D7}"/>
-              </a:ext>
-            </a:extLst>
-          </p:cNvPr>
-          <p:cNvSpPr txBox="1"/>
-          <p:nvPr/>
-        </p:nvSpPr>
-        <p:spPr>
-          <a:xfrm>
-            <a:off x="4699000" y="3454400"/>
-            <a:ext cx="6477000" cy="685800"/>
-          </a:xfrm>
-          <a:prstGeom prst="rect">
-            <a:avLst/>
-          </a:prstGeom>
-          <a:noFill/>
-        </p:spPr>
-        <p:txBody>
-          <a:bodyPr vertOverflow="overflow" vert="horz" wrap="square" rtlCol="0" anchor="ctr" anchorCtr="0">
-            <a:noAutofit/>
-          </a:bodyPr>
-          <a:lstStyle/>
-          <a:p>
-            <a:pPr algn="l"/>
-            <a:r>
-              <a:rPr lang="en-US" sz="1500">
-                <a:solidFill>
-                  <a:srgbClr val="374151"/>
-                </a:solidFill>
-              </a:rPr>
-              <a:t>Tinjau seluruh isian tiap survey.</a:t>
-            </a:r>
-          </a:p>
-        </p:txBody>
-      </p:sp>
-      <p:sp>
-        <p:nvSpPr>
-          <p:cNvPr id="15" name="Rounded Rectangle 14">
-            <a:extLst>
-              <a:ext uri="{FF2B5EF4-FFF2-40B4-BE49-F238E27FC236}">
-                <a16:creationId xmlns:a16="http://schemas.microsoft.com/office/drawing/2014/main" id="{27E1BB97-217F-A64C-9D86-1CC31EBEC6EE}"/>
+              <a:t>Pendataan seluruh wilayah Indonesia.</a:t>
+            </a:r>
+          </a:p>
+        </p:txBody>
+      </p:sp>
+      <p:sp>
+        <p:nvSpPr>
+          <p:cNvPr id="12" name="Oval 11">
+            <a:extLst>
+              <a:ext uri="{FF2B5EF4-FFF2-40B4-BE49-F238E27FC236}">
+                <a16:creationId xmlns:a16="http://schemas.microsoft.com/office/drawing/2014/main" id="{0E6DFA05-57A7-4D4A-A9C5-8D5C2B816CAD}"/>
               </a:ext>
             </a:extLst>
           </p:cNvPr>
@@ -15164,64 +13934,8 @@
         </p:nvSpPr>
         <p:spPr>
           <a:xfrm>
-            <a:off x="762000" y="4229100"/>
-            <a:ext cx="10668000" cy="685800"/>
-          </a:xfrm>
-          <a:prstGeom prst="roundRect">
-            <a:avLst/>
-          </a:prstGeom>
-          <a:solidFill>
-            <a:srgbClr val="FFFFFF"/>
-          </a:solidFill>
-          <a:ln w="12700" cap="flat" cmpd="sng" algn="ctr">
-            <a:solidFill>
-              <a:srgbClr val="E5E7EB"/>
-            </a:solidFill>
-            <a:prstDash val="solid"/>
-            <a:miter lim="800000"/>
-          </a:ln>
-        </p:spPr>
-        <p:style>
-          <a:lnRef idx="2">
-            <a:schemeClr val="accent1">
-              <a:shade val="15000"/>
-            </a:schemeClr>
-          </a:lnRef>
-          <a:fillRef idx="1">
-            <a:schemeClr val="accent1"/>
-          </a:fillRef>
-          <a:effectRef idx="0">
-            <a:schemeClr val="accent1"/>
-          </a:effectRef>
-          <a:fontRef idx="minor">
-            <a:schemeClr val="lt1"/>
-          </a:fontRef>
-        </p:style>
-        <p:txBody>
-          <a:bodyPr vertOverflow="clip" horzOverflow="clip" rtlCol="0" anchor="t"/>
-          <a:lstStyle/>
-          <a:p>
-            <a:pPr algn="l"/>
-            <a:endParaRPr lang="en-US"/>
-          </a:p>
-        </p:txBody>
-      </p:sp>
-      <p:sp>
-        <p:nvSpPr>
-          <p:cNvPr id="16" name="Oval 15">
-            <a:extLst>
-              <a:ext uri="{FF2B5EF4-FFF2-40B4-BE49-F238E27FC236}">
-                <a16:creationId xmlns:a16="http://schemas.microsoft.com/office/drawing/2014/main" id="{74A6218E-2DF2-2340-AD3D-E0D97A59DB62}"/>
-              </a:ext>
-            </a:extLst>
-          </p:cNvPr>
-          <p:cNvSpPr/>
-          <p:nvPr/>
-        </p:nvSpPr>
-        <p:spPr>
-          <a:xfrm>
-            <a:off x="914400" y="4330700"/>
-            <a:ext cx="482600" cy="482600"/>
+            <a:off x="2159000" y="4470400"/>
+            <a:ext cx="762000" cy="762000"/>
           </a:xfrm>
           <a:prstGeom prst="ellipse">
             <a:avLst/>
@@ -15252,29 +13966,60 @@
           </a:fontRef>
         </p:style>
         <p:txBody>
-          <a:bodyPr vertOverflow="clip" horzOverflow="clip" wrap="none" rtlCol="0" anchor="ctr" anchorCtr="0">
+          <a:bodyPr vertOverflow="clip" horzOverflow="clip" rtlCol="0" anchor="t"/>
+          <a:lstStyle/>
+          <a:p>
+            <a:pPr algn="l"/>
+            <a:endParaRPr lang="en-US" dirty="0"/>
+          </a:p>
+        </p:txBody>
+      </p:sp>
+      <p:sp>
+        <p:nvSpPr>
+          <p:cNvPr id="13" name="TextBox 12">
+            <a:extLst>
+              <a:ext uri="{FF2B5EF4-FFF2-40B4-BE49-F238E27FC236}">
+                <a16:creationId xmlns:a16="http://schemas.microsoft.com/office/drawing/2014/main" id="{D4A3340E-E817-414A-9B2B-A3D07E852DEC}"/>
+              </a:ext>
+            </a:extLst>
+          </p:cNvPr>
+          <p:cNvSpPr txBox="1"/>
+          <p:nvPr/>
+        </p:nvSpPr>
+        <p:spPr>
+          <a:xfrm>
+            <a:off x="889000" y="5384800"/>
+            <a:ext cx="3302000" cy="355600"/>
+          </a:xfrm>
+          <a:prstGeom prst="rect">
+            <a:avLst/>
+          </a:prstGeom>
+          <a:noFill/>
+        </p:spPr>
+        <p:txBody>
+          <a:bodyPr vertOverflow="overflow" vert="horz" wrap="square" rtlCol="0" anchor="t">
             <a:noAutofit/>
           </a:bodyPr>
           <a:lstStyle/>
           <a:p>
             <a:pPr algn="l"/>
             <a:r>
-              <a:rPr lang="en-US" sz="1700" b="1">
-                <a:solidFill>
-                  <a:srgbClr val="FFFFFF"/>
+              <a:rPr lang="en-US" sz="1600" b="1">
+                <a:solidFill>
+                  <a:srgbClr val="1A1A1A"/>
                 </a:solidFill>
               </a:rPr>
-              <a:t>4</a:t>
-            </a:r>
-          </a:p>
-        </p:txBody>
-      </p:sp>
-      <p:sp>
-        <p:nvSpPr>
-          <p:cNvPr id="17" name="TextBox 16">
-            <a:extLst>
-              <a:ext uri="{FF2B5EF4-FFF2-40B4-BE49-F238E27FC236}">
-                <a16:creationId xmlns:a16="http://schemas.microsoft.com/office/drawing/2014/main" id="{0793D6EA-771C-1A49-9923-25FD68D28DE8}"/>
+              <a:t>Alur Verifikasi</a:t>
+            </a:r>
+          </a:p>
+        </p:txBody>
+      </p:sp>
+      <p:sp>
+        <p:nvSpPr>
+          <p:cNvPr id="14" name="TextBox 13">
+            <a:extLst>
+              <a:ext uri="{FF2B5EF4-FFF2-40B4-BE49-F238E27FC236}">
+                <a16:creationId xmlns:a16="http://schemas.microsoft.com/office/drawing/2014/main" id="{156343F0-FB42-104B-8B88-8C8EE12028B2}"/>
               </a:ext>
             </a:extLst>
           </p:cNvPr>
@@ -15283,8 +14028,8 @@
         </p:nvSpPr>
         <p:spPr>
           <a:xfrm>
-            <a:off x="1600200" y="4229100"/>
-            <a:ext cx="2921000" cy="685800"/>
+            <a:off x="990600" y="5765800"/>
+            <a:ext cx="3098800" cy="635000"/>
           </a:xfrm>
           <a:prstGeom prst="rect">
             <a:avLst/>
@@ -15292,69 +14037,29 @@
           <a:noFill/>
         </p:spPr>
         <p:txBody>
-          <a:bodyPr vertOverflow="overflow" vert="horz" wrap="none" rtlCol="0" anchor="ctr" anchorCtr="0">
+          <a:bodyPr vertOverflow="overflow" vert="horz" wrap="square" rtlCol="0" anchor="t">
             <a:noAutofit/>
           </a:bodyPr>
           <a:lstStyle/>
           <a:p>
             <a:pPr algn="l"/>
             <a:r>
-              <a:rPr lang="en-US" sz="1600" b="1">
-                <a:solidFill>
-                  <a:srgbClr val="2A68A8"/>
+              <a:rPr lang="en-US" sz="1400">
+                <a:solidFill>
+                  <a:srgbClr val="374151"/>
                 </a:solidFill>
               </a:rPr>
-              <a:t>Setujui / Tolak</a:t>
-            </a:r>
-          </a:p>
-        </p:txBody>
-      </p:sp>
-      <p:sp>
-        <p:nvSpPr>
-          <p:cNvPr id="18" name="TextBox 17">
-            <a:extLst>
-              <a:ext uri="{FF2B5EF4-FFF2-40B4-BE49-F238E27FC236}">
-                <a16:creationId xmlns:a16="http://schemas.microsoft.com/office/drawing/2014/main" id="{4F69CC8C-CC30-D04F-98EA-11CFE449DBDA}"/>
-              </a:ext>
-            </a:extLst>
-          </p:cNvPr>
-          <p:cNvSpPr txBox="1"/>
-          <p:nvPr/>
-        </p:nvSpPr>
-        <p:spPr>
-          <a:xfrm>
-            <a:off x="4699000" y="4229100"/>
-            <a:ext cx="6477000" cy="685800"/>
-          </a:xfrm>
-          <a:prstGeom prst="rect">
-            <a:avLst/>
-          </a:prstGeom>
-          <a:noFill/>
-        </p:spPr>
-        <p:txBody>
-          <a:bodyPr vertOverflow="overflow" vert="horz" wrap="square" rtlCol="0" anchor="ctr" anchorCtr="0">
-            <a:noAutofit/>
-          </a:bodyPr>
-          <a:lstStyle/>
-          <a:p>
-            <a:pPr algn="l"/>
-            <a:r>
-              <a:rPr lang="en-US" sz="1500">
-                <a:solidFill>
-                  <a:srgbClr val="374151"/>
-                </a:solidFill>
-              </a:rPr>
-              <a:t>Putuskan dengan catatan alasan.</a:t>
-            </a:r>
-          </a:p>
-        </p:txBody>
-      </p:sp>
-      <p:sp>
-        <p:nvSpPr>
-          <p:cNvPr id="19" name="Rounded Rectangle 18">
-            <a:extLst>
-              <a:ext uri="{FF2B5EF4-FFF2-40B4-BE49-F238E27FC236}">
-                <a16:creationId xmlns:a16="http://schemas.microsoft.com/office/drawing/2014/main" id="{7F4C1D8A-5BCF-DF41-862C-E08F579E35D1}"/>
+              <a:t>Jaminan kualitas setiap data.</a:t>
+            </a:r>
+          </a:p>
+        </p:txBody>
+      </p:sp>
+      <p:sp>
+        <p:nvSpPr>
+          <p:cNvPr id="15" name="Oval 14">
+            <a:extLst>
+              <a:ext uri="{FF2B5EF4-FFF2-40B4-BE49-F238E27FC236}">
+                <a16:creationId xmlns:a16="http://schemas.microsoft.com/office/drawing/2014/main" id="{1E6A267B-EA8F-4842-90FA-252B7EE570EC}"/>
               </a:ext>
             </a:extLst>
           </p:cNvPr>
@@ -15363,64 +14068,8 @@
         </p:nvSpPr>
         <p:spPr>
           <a:xfrm>
-            <a:off x="762000" y="5003800"/>
-            <a:ext cx="10668000" cy="685800"/>
-          </a:xfrm>
-          <a:prstGeom prst="roundRect">
-            <a:avLst/>
-          </a:prstGeom>
-          <a:solidFill>
-            <a:srgbClr val="F5F7F7"/>
-          </a:solidFill>
-          <a:ln w="12700" cap="flat" cmpd="sng" algn="ctr">
-            <a:solidFill>
-              <a:srgbClr val="E5E7EB"/>
-            </a:solidFill>
-            <a:prstDash val="solid"/>
-            <a:miter lim="800000"/>
-          </a:ln>
-        </p:spPr>
-        <p:style>
-          <a:lnRef idx="2">
-            <a:schemeClr val="accent1">
-              <a:shade val="15000"/>
-            </a:schemeClr>
-          </a:lnRef>
-          <a:fillRef idx="1">
-            <a:schemeClr val="accent1"/>
-          </a:fillRef>
-          <a:effectRef idx="0">
-            <a:schemeClr val="accent1"/>
-          </a:effectRef>
-          <a:fontRef idx="minor">
-            <a:schemeClr val="lt1"/>
-          </a:fontRef>
-        </p:style>
-        <p:txBody>
-          <a:bodyPr vertOverflow="clip" horzOverflow="clip" rtlCol="0" anchor="t"/>
-          <a:lstStyle/>
-          <a:p>
-            <a:pPr algn="l"/>
-            <a:endParaRPr lang="en-US"/>
-          </a:p>
-        </p:txBody>
-      </p:sp>
-      <p:sp>
-        <p:nvSpPr>
-          <p:cNvPr id="20" name="Oval 19">
-            <a:extLst>
-              <a:ext uri="{FF2B5EF4-FFF2-40B4-BE49-F238E27FC236}">
-                <a16:creationId xmlns:a16="http://schemas.microsoft.com/office/drawing/2014/main" id="{0FB8EE44-8F39-5146-8430-78EA504E8214}"/>
-              </a:ext>
-            </a:extLst>
-          </p:cNvPr>
-          <p:cNvSpPr/>
-          <p:nvPr/>
-        </p:nvSpPr>
-        <p:spPr>
-          <a:xfrm>
-            <a:off x="914400" y="5105400"/>
-            <a:ext cx="482600" cy="482600"/>
+            <a:off x="5715000" y="4470400"/>
+            <a:ext cx="762000" cy="762000"/>
           </a:xfrm>
           <a:prstGeom prst="ellipse">
             <a:avLst/>
@@ -15451,29 +14100,60 @@
           </a:fontRef>
         </p:style>
         <p:txBody>
-          <a:bodyPr vertOverflow="clip" horzOverflow="clip" wrap="none" rtlCol="0" anchor="ctr" anchorCtr="0">
+          <a:bodyPr vertOverflow="clip" horzOverflow="clip" rtlCol="0" anchor="t"/>
+          <a:lstStyle/>
+          <a:p>
+            <a:pPr algn="l"/>
+            <a:endParaRPr lang="en-US" dirty="0"/>
+          </a:p>
+        </p:txBody>
+      </p:sp>
+      <p:sp>
+        <p:nvSpPr>
+          <p:cNvPr id="16" name="TextBox 15">
+            <a:extLst>
+              <a:ext uri="{FF2B5EF4-FFF2-40B4-BE49-F238E27FC236}">
+                <a16:creationId xmlns:a16="http://schemas.microsoft.com/office/drawing/2014/main" id="{6837F9F0-A0C1-0146-AF9D-F4FFB5DBB088}"/>
+              </a:ext>
+            </a:extLst>
+          </p:cNvPr>
+          <p:cNvSpPr txBox="1"/>
+          <p:nvPr/>
+        </p:nvSpPr>
+        <p:spPr>
+          <a:xfrm>
+            <a:off x="4445000" y="5384800"/>
+            <a:ext cx="3302000" cy="355600"/>
+          </a:xfrm>
+          <a:prstGeom prst="rect">
+            <a:avLst/>
+          </a:prstGeom>
+          <a:noFill/>
+        </p:spPr>
+        <p:txBody>
+          <a:bodyPr vertOverflow="overflow" vert="horz" wrap="square" rtlCol="0" anchor="t">
             <a:noAutofit/>
           </a:bodyPr>
           <a:lstStyle/>
           <a:p>
             <a:pPr algn="l"/>
             <a:r>
-              <a:rPr lang="en-US" sz="1700" b="1">
-                <a:solidFill>
-                  <a:srgbClr val="FFFFFF"/>
+              <a:rPr lang="en-US" sz="1600" b="1">
+                <a:solidFill>
+                  <a:srgbClr val="1A1A1A"/>
                 </a:solidFill>
               </a:rPr>
-              <a:t>5</a:t>
-            </a:r>
-          </a:p>
-        </p:txBody>
-      </p:sp>
-      <p:sp>
-        <p:nvSpPr>
-          <p:cNvPr id="21" name="TextBox 20">
-            <a:extLst>
-              <a:ext uri="{FF2B5EF4-FFF2-40B4-BE49-F238E27FC236}">
-                <a16:creationId xmlns:a16="http://schemas.microsoft.com/office/drawing/2014/main" id="{4BADFA2B-89A5-564D-A1EA-9DF114B92BF5}"/>
+              <a:t>Isi di Lapangan</a:t>
+            </a:r>
+          </a:p>
+        </p:txBody>
+      </p:sp>
+      <p:sp>
+        <p:nvSpPr>
+          <p:cNvPr id="17" name="TextBox 16">
+            <a:extLst>
+              <a:ext uri="{FF2B5EF4-FFF2-40B4-BE49-F238E27FC236}">
+                <a16:creationId xmlns:a16="http://schemas.microsoft.com/office/drawing/2014/main" id="{AF54EE7F-8975-A648-A965-2E665A87C310}"/>
               </a:ext>
             </a:extLst>
           </p:cNvPr>
@@ -15482,8 +14162,8 @@
         </p:nvSpPr>
         <p:spPr>
           <a:xfrm>
-            <a:off x="1600200" y="5003800"/>
-            <a:ext cx="2921000" cy="685800"/>
+            <a:off x="4546600" y="5765800"/>
+            <a:ext cx="3098800" cy="635000"/>
           </a:xfrm>
           <a:prstGeom prst="rect">
             <a:avLst/>
@@ -15491,69 +14171,29 @@
           <a:noFill/>
         </p:spPr>
         <p:txBody>
-          <a:bodyPr vertOverflow="overflow" vert="horz" wrap="none" rtlCol="0" anchor="ctr" anchorCtr="0">
+          <a:bodyPr vertOverflow="overflow" vert="horz" wrap="square" rtlCol="0" anchor="t">
             <a:noAutofit/>
           </a:bodyPr>
           <a:lstStyle/>
           <a:p>
             <a:pPr algn="l"/>
             <a:r>
-              <a:rPr lang="en-US" sz="1600" b="1">
-                <a:solidFill>
-                  <a:srgbClr val="2A68A8"/>
+              <a:rPr lang="en-US" sz="1400">
+                <a:solidFill>
+                  <a:srgbClr val="374151"/>
                 </a:solidFill>
               </a:rPr>
-              <a:t>Masuk Direktori</a:t>
-            </a:r>
-          </a:p>
-        </p:txBody>
-      </p:sp>
-      <p:sp>
-        <p:nvSpPr>
-          <p:cNvPr id="22" name="TextBox 21">
-            <a:extLst>
-              <a:ext uri="{FF2B5EF4-FFF2-40B4-BE49-F238E27FC236}">
-                <a16:creationId xmlns:a16="http://schemas.microsoft.com/office/drawing/2014/main" id="{61227AA8-8FC4-6842-8D02-F060F17FDA7A}"/>
-              </a:ext>
-            </a:extLst>
-          </p:cNvPr>
-          <p:cNvSpPr txBox="1"/>
-          <p:nvPr/>
-        </p:nvSpPr>
-        <p:spPr>
-          <a:xfrm>
-            <a:off x="4699000" y="5003800"/>
-            <a:ext cx="6477000" cy="685800"/>
-          </a:xfrm>
-          <a:prstGeom prst="rect">
-            <a:avLst/>
-          </a:prstGeom>
-          <a:noFill/>
-        </p:spPr>
-        <p:txBody>
-          <a:bodyPr vertOverflow="overflow" vert="horz" wrap="square" rtlCol="0" anchor="ctr" anchorCtr="0">
-            <a:noAutofit/>
-          </a:bodyPr>
-          <a:lstStyle/>
-          <a:p>
-            <a:pPr algn="l"/>
-            <a:r>
-              <a:rPr lang="en-US" sz="1500">
-                <a:solidFill>
-                  <a:srgbClr val="374151"/>
-                </a:solidFill>
-              </a:rPr>
-              <a:t>Data disetujui tampil di direktori.</a:t>
-            </a:r>
-          </a:p>
-        </p:txBody>
-      </p:sp>
-      <p:sp>
-        <p:nvSpPr>
-          <p:cNvPr id="23" name="Rounded Rectangle 22">
-            <a:extLst>
-              <a:ext uri="{FF2B5EF4-FFF2-40B4-BE49-F238E27FC236}">
-                <a16:creationId xmlns:a16="http://schemas.microsoft.com/office/drawing/2014/main" id="{AB246DCC-111C-C648-8E88-2E187D2528C5}"/>
+              <a:t>Sync otomatis + unggah foto.</a:t>
+            </a:r>
+          </a:p>
+        </p:txBody>
+      </p:sp>
+      <p:sp>
+        <p:nvSpPr>
+          <p:cNvPr id="18" name="Oval 17">
+            <a:extLst>
+              <a:ext uri="{FF2B5EF4-FFF2-40B4-BE49-F238E27FC236}">
+                <a16:creationId xmlns:a16="http://schemas.microsoft.com/office/drawing/2014/main" id="{85985469-14A9-1948-BF50-D89C3F541891}"/>
               </a:ext>
             </a:extLst>
           </p:cNvPr>
@@ -15562,64 +14202,8 @@
         </p:nvSpPr>
         <p:spPr>
           <a:xfrm>
-            <a:off x="762000" y="5778500"/>
-            <a:ext cx="10668000" cy="685800"/>
-          </a:xfrm>
-          <a:prstGeom prst="roundRect">
-            <a:avLst/>
-          </a:prstGeom>
-          <a:solidFill>
-            <a:srgbClr val="FFFFFF"/>
-          </a:solidFill>
-          <a:ln w="12700" cap="flat" cmpd="sng" algn="ctr">
-            <a:solidFill>
-              <a:srgbClr val="E5E7EB"/>
-            </a:solidFill>
-            <a:prstDash val="solid"/>
-            <a:miter lim="800000"/>
-          </a:ln>
-        </p:spPr>
-        <p:style>
-          <a:lnRef idx="2">
-            <a:schemeClr val="accent1">
-              <a:shade val="15000"/>
-            </a:schemeClr>
-          </a:lnRef>
-          <a:fillRef idx="1">
-            <a:schemeClr val="accent1"/>
-          </a:fillRef>
-          <a:effectRef idx="0">
-            <a:schemeClr val="accent1"/>
-          </a:effectRef>
-          <a:fontRef idx="minor">
-            <a:schemeClr val="lt1"/>
-          </a:fontRef>
-        </p:style>
-        <p:txBody>
-          <a:bodyPr vertOverflow="clip" horzOverflow="clip" rtlCol="0" anchor="t"/>
-          <a:lstStyle/>
-          <a:p>
-            <a:pPr algn="l"/>
-            <a:endParaRPr lang="en-US"/>
-          </a:p>
-        </p:txBody>
-      </p:sp>
-      <p:sp>
-        <p:nvSpPr>
-          <p:cNvPr id="24" name="Oval 23">
-            <a:extLst>
-              <a:ext uri="{FF2B5EF4-FFF2-40B4-BE49-F238E27FC236}">
-                <a16:creationId xmlns:a16="http://schemas.microsoft.com/office/drawing/2014/main" id="{338C0845-E7F3-4141-B6C5-C60A415D6408}"/>
-              </a:ext>
-            </a:extLst>
-          </p:cNvPr>
-          <p:cNvSpPr/>
-          <p:nvPr/>
-        </p:nvSpPr>
-        <p:spPr>
-          <a:xfrm>
-            <a:off x="914400" y="5880100"/>
-            <a:ext cx="482600" cy="482600"/>
+            <a:off x="9271000" y="4470400"/>
+            <a:ext cx="762000" cy="762000"/>
           </a:xfrm>
           <a:prstGeom prst="ellipse">
             <a:avLst/>
@@ -15650,29 +14234,60 @@
           </a:fontRef>
         </p:style>
         <p:txBody>
-          <a:bodyPr vertOverflow="clip" horzOverflow="clip" wrap="none" rtlCol="0" anchor="ctr" anchorCtr="0">
+          <a:bodyPr vertOverflow="clip" horzOverflow="clip" rtlCol="0" anchor="t"/>
+          <a:lstStyle/>
+          <a:p>
+            <a:pPr algn="l"/>
+            <a:endParaRPr lang="en-US"/>
+          </a:p>
+        </p:txBody>
+      </p:sp>
+      <p:sp>
+        <p:nvSpPr>
+          <p:cNvPr id="19" name="TextBox 18">
+            <a:extLst>
+              <a:ext uri="{FF2B5EF4-FFF2-40B4-BE49-F238E27FC236}">
+                <a16:creationId xmlns:a16="http://schemas.microsoft.com/office/drawing/2014/main" id="{20932C45-F988-FD43-BE64-EC6138C4F594}"/>
+              </a:ext>
+            </a:extLst>
+          </p:cNvPr>
+          <p:cNvSpPr txBox="1"/>
+          <p:nvPr/>
+        </p:nvSpPr>
+        <p:spPr>
+          <a:xfrm>
+            <a:off x="8001000" y="5384800"/>
+            <a:ext cx="3302000" cy="355600"/>
+          </a:xfrm>
+          <a:prstGeom prst="rect">
+            <a:avLst/>
+          </a:prstGeom>
+          <a:noFill/>
+        </p:spPr>
+        <p:txBody>
+          <a:bodyPr vertOverflow="overflow" vert="horz" wrap="square" rtlCol="0" anchor="t">
             <a:noAutofit/>
           </a:bodyPr>
           <a:lstStyle/>
           <a:p>
             <a:pPr algn="l"/>
             <a:r>
-              <a:rPr lang="en-US" sz="1700" b="1">
-                <a:solidFill>
-                  <a:srgbClr val="FFFFFF"/>
+              <a:rPr lang="en-US" sz="1600" b="1">
+                <a:solidFill>
+                  <a:srgbClr val="1A1A1A"/>
                 </a:solidFill>
               </a:rPr>
-              <a:t>6</a:t>
-            </a:r>
-          </a:p>
-        </p:txBody>
-      </p:sp>
-      <p:sp>
-        <p:nvSpPr>
-          <p:cNvPr id="25" name="TextBox 24">
-            <a:extLst>
-              <a:ext uri="{FF2B5EF4-FFF2-40B4-BE49-F238E27FC236}">
-                <a16:creationId xmlns:a16="http://schemas.microsoft.com/office/drawing/2014/main" id="{E870EDD5-0C53-5244-B44D-4C0737DE00BB}"/>
+              <a:t>Riwayat &amp; Audit</a:t>
+            </a:r>
+          </a:p>
+        </p:txBody>
+      </p:sp>
+      <p:sp>
+        <p:nvSpPr>
+          <p:cNvPr id="20" name="TextBox 19">
+            <a:extLst>
+              <a:ext uri="{FF2B5EF4-FFF2-40B4-BE49-F238E27FC236}">
+                <a16:creationId xmlns:a16="http://schemas.microsoft.com/office/drawing/2014/main" id="{47248E57-A557-3941-B007-21F63E521104}"/>
               </a:ext>
             </a:extLst>
           </p:cNvPr>
@@ -15681,8 +14296,8 @@
         </p:nvSpPr>
         <p:spPr>
           <a:xfrm>
-            <a:off x="1600200" y="5778500"/>
-            <a:ext cx="2921000" cy="685800"/>
+            <a:off x="8102600" y="5765800"/>
+            <a:ext cx="3098800" cy="635000"/>
           </a:xfrm>
           <a:prstGeom prst="rect">
             <a:avLst/>
@@ -15690,67 +14305,201 @@
           <a:noFill/>
         </p:spPr>
         <p:txBody>
-          <a:bodyPr vertOverflow="overflow" vert="horz" wrap="none" rtlCol="0" anchor="ctr" anchorCtr="0">
+          <a:bodyPr vertOverflow="overflow" vert="horz" wrap="square" rtlCol="0" anchor="t">
             <a:noAutofit/>
           </a:bodyPr>
           <a:lstStyle/>
           <a:p>
             <a:pPr algn="l"/>
             <a:r>
-              <a:rPr lang="en-US" sz="1600" b="1">
-                <a:solidFill>
-                  <a:srgbClr val="2A68A8"/>
+              <a:rPr lang="en-US" sz="1400">
+                <a:solidFill>
+                  <a:srgbClr val="374151"/>
                 </a:solidFill>
               </a:rPr>
-              <a:t>Log Aktivitas</a:t>
-            </a:r>
-          </a:p>
-        </p:txBody>
-      </p:sp>
-      <p:sp>
-        <p:nvSpPr>
-          <p:cNvPr id="26" name="TextBox 25">
-            <a:extLst>
-              <a:ext uri="{FF2B5EF4-FFF2-40B4-BE49-F238E27FC236}">
-                <a16:creationId xmlns:a16="http://schemas.microsoft.com/office/drawing/2014/main" id="{3B09D311-0D92-734B-A198-DEE0565ABCEB}"/>
-              </a:ext>
-            </a:extLst>
-          </p:cNvPr>
-          <p:cNvSpPr txBox="1"/>
-          <p:nvPr/>
-        </p:nvSpPr>
-        <p:spPr>
-          <a:xfrm>
-            <a:off x="4699000" y="5778500"/>
-            <a:ext cx="6477000" cy="685800"/>
+              <a:t>Setiap perubahan tercatat.</a:t>
+            </a:r>
+          </a:p>
+        </p:txBody>
+      </p:sp>
+      <p:pic>
+        <p:nvPicPr>
+          <p:cNvPr id="21" name="Graphic 21"/>
+          <p:cNvPicPr>
+            <a:picLocks noChangeAspect="1"/>
+          </p:cNvPicPr>
+          <p:nvPr/>
+        </p:nvPicPr>
+        <p:blipFill>
+          <a:blip>
+            <a:extLst>
+              <a:ext uri="{96DAC541-7B7A-43D3-8B79-37D633B846F1}">
+                <asvg:svgBlip xmlns:asvg="http://schemas.microsoft.com/office/drawing/2016/SVG/main" r:embed="rId2"/>
+              </a:ext>
+            </a:extLst>
+          </a:blip>
+          <a:srcRect/>
+          <a:stretch/>
+        </p:blipFill>
+        <p:spPr>
+          <a:xfrm>
+            <a:off x="2336800" y="2209800"/>
+            <a:ext cx="406400" cy="406400"/>
           </a:xfrm>
           <a:prstGeom prst="rect">
             <a:avLst/>
           </a:prstGeom>
-          <a:noFill/>
-        </p:spPr>
-        <p:txBody>
-          <a:bodyPr vertOverflow="overflow" vert="horz" wrap="square" rtlCol="0" anchor="ctr" anchorCtr="0">
-            <a:noAutofit/>
-          </a:bodyPr>
-          <a:lstStyle/>
-          <a:p>
-            <a:pPr algn="l"/>
-            <a:r>
-              <a:rPr lang="en-US" sz="1500">
-                <a:solidFill>
-                  <a:srgbClr val="374151"/>
-                </a:solidFill>
-              </a:rPr>
-              <a:t>Pantau jejak siapa mengubah apa.</a:t>
-            </a:r>
-          </a:p>
-        </p:txBody>
-      </p:sp>
+        </p:spPr>
+      </p:pic>
+      <p:pic>
+        <p:nvPicPr>
+          <p:cNvPr id="22" name="Graphic 22"/>
+          <p:cNvPicPr>
+            <a:picLocks noChangeAspect="1"/>
+          </p:cNvPicPr>
+          <p:nvPr/>
+        </p:nvPicPr>
+        <p:blipFill>
+          <a:blip>
+            <a:extLst>
+              <a:ext uri="{96DAC541-7B7A-43D3-8B79-37D633B846F1}">
+                <asvg:svgBlip xmlns:asvg="http://schemas.microsoft.com/office/drawing/2016/SVG/main" r:embed="rId3"/>
+              </a:ext>
+            </a:extLst>
+          </a:blip>
+          <a:srcRect/>
+          <a:stretch/>
+        </p:blipFill>
+        <p:spPr>
+          <a:xfrm>
+            <a:off x="5918200" y="2235200"/>
+            <a:ext cx="355600" cy="355600"/>
+          </a:xfrm>
+          <a:prstGeom prst="rect">
+            <a:avLst/>
+          </a:prstGeom>
+        </p:spPr>
+      </p:pic>
+      <p:pic>
+        <p:nvPicPr>
+          <p:cNvPr id="23" name="Graphic 23"/>
+          <p:cNvPicPr>
+            <a:picLocks noChangeAspect="1"/>
+          </p:cNvPicPr>
+          <p:nvPr/>
+        </p:nvPicPr>
+        <p:blipFill>
+          <a:blip>
+            <a:extLst>
+              <a:ext uri="{96DAC541-7B7A-43D3-8B79-37D633B846F1}">
+                <asvg:svgBlip xmlns:asvg="http://schemas.microsoft.com/office/drawing/2016/SVG/main" r:embed="rId4"/>
+              </a:ext>
+            </a:extLst>
+          </a:blip>
+          <a:srcRect/>
+          <a:stretch/>
+        </p:blipFill>
+        <p:spPr>
+          <a:xfrm>
+            <a:off x="9474200" y="2235200"/>
+            <a:ext cx="355600" cy="355600"/>
+          </a:xfrm>
+          <a:prstGeom prst="rect">
+            <a:avLst/>
+          </a:prstGeom>
+        </p:spPr>
+      </p:pic>
+      <p:pic>
+        <p:nvPicPr>
+          <p:cNvPr id="24" name="Graphic 24"/>
+          <p:cNvPicPr>
+            <a:picLocks noChangeAspect="1"/>
+          </p:cNvPicPr>
+          <p:nvPr/>
+        </p:nvPicPr>
+        <p:blipFill>
+          <a:blip>
+            <a:extLst>
+              <a:ext uri="{96DAC541-7B7A-43D3-8B79-37D633B846F1}">
+                <asvg:svgBlip xmlns:asvg="http://schemas.microsoft.com/office/drawing/2016/SVG/main" r:embed="rId5"/>
+              </a:ext>
+            </a:extLst>
+          </a:blip>
+          <a:srcRect/>
+          <a:stretch/>
+        </p:blipFill>
+        <p:spPr>
+          <a:xfrm>
+            <a:off x="2336800" y="4648200"/>
+            <a:ext cx="406400" cy="406400"/>
+          </a:xfrm>
+          <a:prstGeom prst="rect">
+            <a:avLst/>
+          </a:prstGeom>
+        </p:spPr>
+      </p:pic>
+      <p:pic>
+        <p:nvPicPr>
+          <p:cNvPr id="25" name="Graphic 25"/>
+          <p:cNvPicPr>
+            <a:picLocks noChangeAspect="1"/>
+          </p:cNvPicPr>
+          <p:nvPr/>
+        </p:nvPicPr>
+        <p:blipFill>
+          <a:blip>
+            <a:extLst>
+              <a:ext uri="{96DAC541-7B7A-43D3-8B79-37D633B846F1}">
+                <asvg:svgBlip xmlns:asvg="http://schemas.microsoft.com/office/drawing/2016/SVG/main" r:embed="rId6"/>
+              </a:ext>
+            </a:extLst>
+          </a:blip>
+          <a:srcRect/>
+          <a:stretch/>
+        </p:blipFill>
+        <p:spPr>
+          <a:xfrm>
+            <a:off x="5905500" y="4660900"/>
+            <a:ext cx="406400" cy="406400"/>
+          </a:xfrm>
+          <a:prstGeom prst="rect">
+            <a:avLst/>
+          </a:prstGeom>
+        </p:spPr>
+      </p:pic>
+      <p:pic>
+        <p:nvPicPr>
+          <p:cNvPr id="26" name="Graphic 26"/>
+          <p:cNvPicPr>
+            <a:picLocks noChangeAspect="1"/>
+          </p:cNvPicPr>
+          <p:nvPr/>
+        </p:nvPicPr>
+        <p:blipFill>
+          <a:blip>
+            <a:extLst>
+              <a:ext uri="{96DAC541-7B7A-43D3-8B79-37D633B846F1}">
+                <asvg:svgBlip xmlns:asvg="http://schemas.microsoft.com/office/drawing/2016/SVG/main" r:embed="rId7"/>
+              </a:ext>
+            </a:extLst>
+          </a:blip>
+          <a:srcRect/>
+          <a:stretch/>
+        </p:blipFill>
+        <p:spPr>
+          <a:xfrm>
+            <a:off x="9474200" y="4648200"/>
+            <a:ext cx="406400" cy="406400"/>
+          </a:xfrm>
+          <a:prstGeom prst="rect">
+            <a:avLst/>
+          </a:prstGeom>
+        </p:spPr>
+      </p:pic>
     </p:spTree>
     <p:extLst>
       <p:ext uri="{BB962C8B-B14F-4D97-AF65-F5344CB8AC3E}">
-        <p14:creationId xmlns:p14="http://schemas.microsoft.com/office/powerpoint/2010/main" val="864952410"/>
+        <p14:creationId xmlns:p14="http://schemas.microsoft.com/office/powerpoint/2010/main" val="3923697559"/>
       </p:ext>
     </p:extLst>
   </p:cSld>

</xml_diff>